<commit_message>
Fix authors list and repo link in slides
</commit_message>
<xml_diff>
--- a/laws_rag_presentation.pptx
+++ b/laws_rag_presentation.pptx
@@ -4,6 +4,9 @@
   <p:sldMasterIdLst>
     <p:sldMasterId id="2147483648" r:id="rId1"/>
   </p:sldMasterIdLst>
+  <p:notesMasterIdLst>
+    <p:notesMasterId r:id="rId12"/>
+  </p:notesMasterIdLst>
   <p:sldIdLst>
     <p:sldId id="256" r:id="rId2"/>
     <p:sldId id="257" r:id="rId3"/>
@@ -16,10 +19,7 @@
     <p:sldId id="264" r:id="rId10"/>
     <p:sldId id="265" r:id="rId11"/>
   </p:sldIdLst>
-  <p:notesMasterIdLst>
-    <p:notesMasterId r:id="rId12"/>
-  </p:notesMasterIdLst>
-  <p:sldSz cx="9144000" cy="5143500"/>
+  <p:sldSz cx="9144000" cy="5143500" type="screen16x9"/>
   <p:notesSz cx="5143500" cy="9144000"/>
   <p:defaultTextStyle>
     <a:lvl1pPr marL="0" algn="l" defTabSz="914400" rtl="0" eaLnBrk="1" latinLnBrk="0" hangingPunct="1">
@@ -113,13 +113,20 @@
       </a:defRPr>
     </a:lvl9pPr>
   </p:defaultTextStyle>
+  <p:extLst>
+    <p:ext uri="{EFAFB233-063F-42B5-8137-9DF3F51BA10A}">
+      <p15:sldGuideLst xmlns:p15="http://schemas.microsoft.com/office/powerpoint/2012/main"/>
+    </p:ext>
+  </p:extLst>
 </p:presentation>
 </file>
 
 <file path=ppt/charts/chart1.xml><?xml version="1.0" encoding="utf-8"?>
-<c:chartSpace xmlns:c="http://schemas.openxmlformats.org/drawingml/2006/chart" xmlns:a="http://schemas.openxmlformats.org/drawingml/2006/main" xmlns:r="http://schemas.openxmlformats.org/officeDocument/2006/relationships">
+<c:chartSpace xmlns:c="http://schemas.openxmlformats.org/drawingml/2006/chart" xmlns:a="http://schemas.openxmlformats.org/drawingml/2006/main" xmlns:r="http://schemas.openxmlformats.org/officeDocument/2006/relationships" xmlns:c16r2="http://schemas.microsoft.com/office/drawing/2015/06/chart">
   <c:date1904 val="0"/>
+  <c:lang val="it-IT"/>
   <c:roundedCorners val="1"/>
+  <c:style val="2"/>
   <c:chart>
     <c:autoTitleDeleted val="1"/>
     <c:plotArea>
@@ -149,51 +156,25 @@
             <a:effectLst/>
           </c:spPr>
           <c:invertIfNegative val="0"/>
-          <c:dLbls>
-            <c:numFmt formatCode="#,##0" sourceLinked="0"/>
-            <c:txPr>
-              <a:bodyPr/>
-              <a:lstStyle/>
-              <a:p>
-                <a:pPr>
-                  <a:defRPr b="0" i="0" strike="noStrike" sz="1200" u="none">
-                    <a:solidFill>
-                      <a:srgbClr val="000000"/>
-                    </a:solidFill>
-                    <a:latin typeface="Arial"/>
-                  </a:defRPr>
-                </a:pPr>
-              </a:p>
-            </c:txPr>
-            <c:showLegendKey val="0"/>
-            <c:showVal val="0"/>
-            <c:showCatName val="0"/>
-            <c:showSerName val="0"/>
-            <c:showPercent val="0"/>
-            <c:showBubbleSize val="0"/>
-            <c:showLeaderLines val="0"/>
-          </c:dLbls>
           <c:cat>
-            <c:multiLvlStrRef>
+            <c:strRef>
               <c:f>Sheet1!$A$2:$A$5</c:f>
-              <c:multiLvlStrCache>
+              <c:strCache>
                 <c:ptCount val="4"/>
-                <c:lvl>
-                  <c:pt idx="0">
-                    <c:v>Recall@1</c:v>
-                  </c:pt>
-                  <c:pt idx="1">
-                    <c:v>Recall@3</c:v>
-                  </c:pt>
-                  <c:pt idx="2">
-                    <c:v>Recall@5</c:v>
-                  </c:pt>
-                  <c:pt idx="3">
-                    <c:v>MRR@5</c:v>
-                  </c:pt>
-                </c:lvl>
-              </c:multiLvlStrCache>
-            </c:multiLvlStrRef>
+                <c:pt idx="0">
+                  <c:v>Recall@1</c:v>
+                </c:pt>
+                <c:pt idx="1">
+                  <c:v>Recall@3</c:v>
+                </c:pt>
+                <c:pt idx="2">
+                  <c:v>Recall@5</c:v>
+                </c:pt>
+                <c:pt idx="3">
+                  <c:v>MRR@5</c:v>
+                </c:pt>
+              </c:strCache>
+            </c:strRef>
           </c:cat>
           <c:val>
             <c:numRef>
@@ -211,11 +192,16 @@
                   <c:v>0.8</c:v>
                 </c:pt>
                 <c:pt idx="3">
-                  <c:v>0.56</c:v>
+                  <c:v>0.56000000000000005</c:v>
                 </c:pt>
               </c:numCache>
             </c:numRef>
           </c:val>
+          <c:extLst>
+            <c:ext xmlns:c16="http://schemas.microsoft.com/office/drawing/2014/chart" uri="{C3380CC4-5D6E-409C-BE32-E72D297353CC}">
+              <c16:uniqueId val="{00000000-1749-4AF8-9106-1D8CE8379E3C}"/>
+            </c:ext>
+          </c:extLst>
         </c:ser>
         <c:ser>
           <c:idx val="1"/>
@@ -238,51 +224,25 @@
             <a:effectLst/>
           </c:spPr>
           <c:invertIfNegative val="0"/>
-          <c:dLbls>
-            <c:numFmt formatCode="#,##0" sourceLinked="0"/>
-            <c:txPr>
-              <a:bodyPr/>
-              <a:lstStyle/>
-              <a:p>
-                <a:pPr>
-                  <a:defRPr b="0" i="0" strike="noStrike" sz="1200" u="none">
-                    <a:solidFill>
-                      <a:srgbClr val="000000"/>
-                    </a:solidFill>
-                    <a:latin typeface="Arial"/>
-                  </a:defRPr>
-                </a:pPr>
-              </a:p>
-            </c:txPr>
-            <c:showLegendKey val="0"/>
-            <c:showVal val="0"/>
-            <c:showCatName val="0"/>
-            <c:showSerName val="0"/>
-            <c:showPercent val="0"/>
-            <c:showBubbleSize val="0"/>
-            <c:showLeaderLines val="0"/>
-          </c:dLbls>
           <c:cat>
-            <c:multiLvlStrRef>
+            <c:strRef>
               <c:f>Sheet1!$A$2:$A$5</c:f>
-              <c:multiLvlStrCache>
+              <c:strCache>
                 <c:ptCount val="4"/>
-                <c:lvl>
-                  <c:pt idx="0">
-                    <c:v>Recall@1</c:v>
-                  </c:pt>
-                  <c:pt idx="1">
-                    <c:v>Recall@3</c:v>
-                  </c:pt>
-                  <c:pt idx="2">
-                    <c:v>Recall@5</c:v>
-                  </c:pt>
-                  <c:pt idx="3">
-                    <c:v>MRR@5</c:v>
-                  </c:pt>
-                </c:lvl>
-              </c:multiLvlStrCache>
-            </c:multiLvlStrRef>
+                <c:pt idx="0">
+                  <c:v>Recall@1</c:v>
+                </c:pt>
+                <c:pt idx="1">
+                  <c:v>Recall@3</c:v>
+                </c:pt>
+                <c:pt idx="2">
+                  <c:v>Recall@5</c:v>
+                </c:pt>
+                <c:pt idx="3">
+                  <c:v>MRR@5</c:v>
+                </c:pt>
+              </c:strCache>
+            </c:strRef>
           </c:cat>
           <c:val>
             <c:numRef>
@@ -305,6 +265,11 @@
               </c:numCache>
             </c:numRef>
           </c:val>
+          <c:extLst>
+            <c:ext xmlns:c16="http://schemas.microsoft.com/office/drawing/2014/chart" uri="{C3380CC4-5D6E-409C-BE32-E72D297353CC}">
+              <c16:uniqueId val="{00000001-1749-4AF8-9106-1D8CE8379E3C}"/>
+            </c:ext>
+          </c:extLst>
         </c:ser>
         <c:ser>
           <c:idx val="2"/>
@@ -327,51 +292,25 @@
             <a:effectLst/>
           </c:spPr>
           <c:invertIfNegative val="0"/>
-          <c:dLbls>
-            <c:numFmt formatCode="#,##0" sourceLinked="0"/>
-            <c:txPr>
-              <a:bodyPr/>
-              <a:lstStyle/>
-              <a:p>
-                <a:pPr>
-                  <a:defRPr b="0" i="0" strike="noStrike" sz="1200" u="none">
-                    <a:solidFill>
-                      <a:srgbClr val="000000"/>
-                    </a:solidFill>
-                    <a:latin typeface="Arial"/>
-                  </a:defRPr>
-                </a:pPr>
-              </a:p>
-            </c:txPr>
-            <c:showLegendKey val="0"/>
-            <c:showVal val="0"/>
-            <c:showCatName val="0"/>
-            <c:showSerName val="0"/>
-            <c:showPercent val="0"/>
-            <c:showBubbleSize val="0"/>
-            <c:showLeaderLines val="0"/>
-          </c:dLbls>
           <c:cat>
-            <c:multiLvlStrRef>
+            <c:strRef>
               <c:f>Sheet1!$A$2:$A$5</c:f>
-              <c:multiLvlStrCache>
+              <c:strCache>
                 <c:ptCount val="4"/>
-                <c:lvl>
-                  <c:pt idx="0">
-                    <c:v>Recall@1</c:v>
-                  </c:pt>
-                  <c:pt idx="1">
-                    <c:v>Recall@3</c:v>
-                  </c:pt>
-                  <c:pt idx="2">
-                    <c:v>Recall@5</c:v>
-                  </c:pt>
-                  <c:pt idx="3">
-                    <c:v>MRR@5</c:v>
-                  </c:pt>
-                </c:lvl>
-              </c:multiLvlStrCache>
-            </c:multiLvlStrRef>
+                <c:pt idx="0">
+                  <c:v>Recall@1</c:v>
+                </c:pt>
+                <c:pt idx="1">
+                  <c:v>Recall@3</c:v>
+                </c:pt>
+                <c:pt idx="2">
+                  <c:v>Recall@5</c:v>
+                </c:pt>
+                <c:pt idx="3">
+                  <c:v>MRR@5</c:v>
+                </c:pt>
+              </c:strCache>
+            </c:strRef>
           </c:cat>
           <c:val>
             <c:numRef>
@@ -394,6 +333,11 @@
               </c:numCache>
             </c:numRef>
           </c:val>
+          <c:extLst>
+            <c:ext xmlns:c16="http://schemas.microsoft.com/office/drawing/2014/chart" uri="{C3380CC4-5D6E-409C-BE32-E72D297353CC}">
+              <c16:uniqueId val="{00000002-1749-4AF8-9106-1D8CE8379E3C}"/>
+            </c:ext>
+          </c:extLst>
         </c:ser>
         <c:ser>
           <c:idx val="3"/>
@@ -416,51 +360,25 @@
             <a:effectLst/>
           </c:spPr>
           <c:invertIfNegative val="0"/>
-          <c:dLbls>
-            <c:numFmt formatCode="#,##0" sourceLinked="0"/>
-            <c:txPr>
-              <a:bodyPr/>
-              <a:lstStyle/>
-              <a:p>
-                <a:pPr>
-                  <a:defRPr b="0" i="0" strike="noStrike" sz="1200" u="none">
-                    <a:solidFill>
-                      <a:srgbClr val="000000"/>
-                    </a:solidFill>
-                    <a:latin typeface="Arial"/>
-                  </a:defRPr>
-                </a:pPr>
-              </a:p>
-            </c:txPr>
-            <c:showLegendKey val="0"/>
-            <c:showVal val="0"/>
-            <c:showCatName val="0"/>
-            <c:showSerName val="0"/>
-            <c:showPercent val="0"/>
-            <c:showBubbleSize val="0"/>
-            <c:showLeaderLines val="0"/>
-          </c:dLbls>
           <c:cat>
-            <c:multiLvlStrRef>
+            <c:strRef>
               <c:f>Sheet1!$A$2:$A$5</c:f>
-              <c:multiLvlStrCache>
+              <c:strCache>
                 <c:ptCount val="4"/>
-                <c:lvl>
-                  <c:pt idx="0">
-                    <c:v>Recall@1</c:v>
-                  </c:pt>
-                  <c:pt idx="1">
-                    <c:v>Recall@3</c:v>
-                  </c:pt>
-                  <c:pt idx="2">
-                    <c:v>Recall@5</c:v>
-                  </c:pt>
-                  <c:pt idx="3">
-                    <c:v>MRR@5</c:v>
-                  </c:pt>
-                </c:lvl>
-              </c:multiLvlStrCache>
-            </c:multiLvlStrRef>
+                <c:pt idx="0">
+                  <c:v>Recall@1</c:v>
+                </c:pt>
+                <c:pt idx="1">
+                  <c:v>Recall@3</c:v>
+                </c:pt>
+                <c:pt idx="2">
+                  <c:v>Recall@5</c:v>
+                </c:pt>
+                <c:pt idx="3">
+                  <c:v>MRR@5</c:v>
+                </c:pt>
+              </c:strCache>
+            </c:strRef>
           </c:cat>
           <c:val>
             <c:numRef>
@@ -483,36 +401,23 @@
               </c:numCache>
             </c:numRef>
           </c:val>
+          <c:extLst>
+            <c:ext xmlns:c16="http://schemas.microsoft.com/office/drawing/2014/chart" uri="{C3380CC4-5D6E-409C-BE32-E72D297353CC}">
+              <c16:uniqueId val="{00000003-1749-4AF8-9106-1D8CE8379E3C}"/>
+            </c:ext>
+          </c:extLst>
         </c:ser>
         <c:dLbls>
-          <c:numFmt formatCode="#,##0" sourceLinked="0"/>
-          <c:txPr>
-            <a:bodyPr/>
-            <a:lstStyle/>
-            <a:p>
-              <a:pPr>
-                <a:defRPr b="0" i="0" strike="noStrike" sz="1200" u="none">
-                  <a:solidFill>
-                    <a:srgbClr val="000000"/>
-                  </a:solidFill>
-                  <a:latin typeface="Arial"/>
-                </a:defRPr>
-              </a:pPr>
-            </a:p>
-          </c:txPr>
           <c:showLegendKey val="0"/>
           <c:showVal val="0"/>
           <c:showCatName val="0"/>
           <c:showSerName val="0"/>
           <c:showPercent val="0"/>
           <c:showBubbleSize val="0"/>
-          <c:showLeaderLines val="0"/>
         </c:dLbls>
         <c:gapWidth val="150"/>
-        <c:overlap val="0"/>
         <c:axId val="2094734554"/>
         <c:axId val="2094734552"/>
-        <c:axId val="2094734556"/>
       </c:barChart>
       <c:catAx>
         <c:axId val="2094734554"/>
@@ -553,6 +458,7 @@
         <c:crosses val="autoZero"/>
         <c:auto val="1"/>
         <c:lblAlgn val="ctr"/>
+        <c:lblOffset val="100"/>
         <c:noMultiLvlLbl val="1"/>
       </c:catAx>
       <c:valAx>
@@ -623,7 +529,7 @@
         <a:lstStyle/>
         <a:p>
           <a:pPr>
-            <a:defRPr sz="900">      </a:defRPr>
+            <a:defRPr sz="900"/>
           </a:pPr>
           <a:endParaRPr lang="en-US"/>
         </a:p>
@@ -631,6 +537,7 @@
     </c:legend>
     <c:plotVisOnly val="1"/>
     <c:dispBlanksAs val="span"/>
+    <c:showDLblsOverMax val="1"/>
   </c:chart>
   <c:spPr>
     <a:solidFill>
@@ -669,234 +576,10 @@
           <a:chExt cx="0" cy="0"/>
         </a:xfrm>
       </p:grpSpPr>
-      <p:sp>
-        <p:nvSpPr>
-          <p:cNvPr id="2" name="Header Placeholder 1"/>
-          <p:cNvSpPr>
-            <a:spLocks noGrp="1"/>
-          </p:cNvSpPr>
-          <p:nvPr>
-            <p:ph type="hdr" sz="quarter"/>
-          </p:nvPr>
-        </p:nvSpPr>
-        <p:spPr>
-          <a:xfrm>
-            <a:off x="0" y="0"/>
-            <a:ext cx="2971800" cy="458788"/>
-          </a:xfrm>
-          <a:prstGeom prst="rect">
-            <a:avLst/>
-          </a:prstGeom>
-        </p:spPr>
-        <p:txBody>
-          <a:bodyPr vert="horz" lIns="91440" tIns="45720" rIns="91440" bIns="45720" rtlCol="0"/>
-          <a:lstStyle>
-            <a:lvl1pPr algn="l">
-              <a:defRPr sz="1200"/>
-            </a:lvl1pPr>
-          </a:lstStyle>
-          <a:p>
-            <a:endParaRPr lang="en-US"/>
-          </a:p>
-        </p:txBody>
-      </p:sp>
-      <p:sp>
-        <p:nvSpPr>
-          <p:cNvPr id="3" name="Date Placeholder 2"/>
-          <p:cNvSpPr>
-            <a:spLocks noGrp="1"/>
-          </p:cNvSpPr>
-          <p:nvPr>
-            <p:ph type="dt" idx="1"/>
-          </p:nvPr>
-        </p:nvSpPr>
-        <p:spPr>
-          <a:xfrm>
-            <a:off x="3884613" y="0"/>
-            <a:ext cx="2971800" cy="458788"/>
-          </a:xfrm>
-          <a:prstGeom prst="rect">
-            <a:avLst/>
-          </a:prstGeom>
-        </p:spPr>
-        <p:txBody>
-          <a:bodyPr vert="horz" lIns="91440" tIns="45720" rIns="91440" bIns="45720" rtlCol="0"/>
-          <a:lstStyle>
-            <a:lvl1pPr algn="r">
-              <a:defRPr sz="1200"/>
-            </a:lvl1pPr>
-          </a:lstStyle>
-          <a:p>
-            <a:fld id="{5282F153-3F37-0F45-9E97-73ACFA13230C}" type="datetimeFigureOut">
-              <a:rPr lang="en-US"/>
-              <a:t>7/23/19</a:t>
-            </a:fld>
-            <a:endParaRPr lang="en-US"/>
-          </a:p>
-        </p:txBody>
-      </p:sp>
-      <p:sp>
-        <p:nvSpPr>
-          <p:cNvPr id="4" name="Slide Image Placeholder 3"/>
-          <p:cNvSpPr>
-            <a:spLocks noGrp="1" noRot="1" noChangeAspect="1"/>
-          </p:cNvSpPr>
-          <p:nvPr>
-            <p:ph type="sldImg" idx="2"/>
-          </p:nvPr>
-        </p:nvSpPr>
-        <p:spPr>
-          <a:xfrm>
-            <a:off x="685800" y="1143000"/>
-            <a:ext cx="5486400" cy="3086100"/>
-          </a:xfrm>
-          <a:prstGeom prst="rect">
-            <a:avLst/>
-          </a:prstGeom>
-          <a:noFill/>
-          <a:ln w="12700">
-            <a:solidFill>
-              <a:prstClr val="black"/>
-            </a:solidFill>
-          </a:ln>
-        </p:spPr>
-        <p:txBody>
-          <a:bodyPr vert="horz" lIns="91440" tIns="45720" rIns="91440" bIns="45720" rtlCol="0" anchor="ctr"/>
-          <a:lstStyle/>
-          <a:p>
-            <a:endParaRPr lang="en-US"/>
-          </a:p>
-        </p:txBody>
-      </p:sp>
-      <p:sp>
-        <p:nvSpPr>
-          <p:cNvPr id="5" name="Notes Placeholder 4"/>
-          <p:cNvSpPr>
-            <a:spLocks noGrp="1"/>
-          </p:cNvSpPr>
-          <p:nvPr>
-            <p:ph type="body" sz="quarter" idx="3"/>
-          </p:nvPr>
-        </p:nvSpPr>
-        <p:spPr>
-          <a:xfrm>
-            <a:off x="685800" y="4400550"/>
-            <a:ext cx="5486400" cy="3600450"/>
-          </a:xfrm>
-          <a:prstGeom prst="rect">
-            <a:avLst/>
-          </a:prstGeom>
-        </p:spPr>
-        <p:txBody>
-          <a:bodyPr vert="horz" lIns="91440" tIns="45720" rIns="91440" bIns="45720" rtlCol="0"/>
-          <a:lstStyle/>
-          <a:p>
-            <a:pPr lvl="0"/>
-            <a:r>
-              <a:rPr lang="en-US"/>
-              <a:t>Click to edit Master text styles</a:t>
-            </a:r>
-          </a:p>
-          <a:p>
-            <a:pPr lvl="1"/>
-            <a:r>
-              <a:rPr lang="en-US"/>
-              <a:t>Second level</a:t>
-            </a:r>
-          </a:p>
-          <a:p>
-            <a:pPr lvl="2"/>
-            <a:r>
-              <a:rPr lang="en-US"/>
-              <a:t>Third level</a:t>
-            </a:r>
-          </a:p>
-          <a:p>
-            <a:pPr lvl="3"/>
-            <a:r>
-              <a:rPr lang="en-US"/>
-              <a:t>Fourth level</a:t>
-            </a:r>
-          </a:p>
-          <a:p>
-            <a:pPr lvl="4"/>
-            <a:r>
-              <a:rPr lang="en-US"/>
-              <a:t>Fifth level</a:t>
-            </a:r>
-          </a:p>
-        </p:txBody>
-      </p:sp>
-      <p:sp>
-        <p:nvSpPr>
-          <p:cNvPr id="6" name="Footer Placeholder 5"/>
-          <p:cNvSpPr>
-            <a:spLocks noGrp="1"/>
-          </p:cNvSpPr>
-          <p:nvPr>
-            <p:ph type="ftr" sz="quarter" idx="4"/>
-          </p:nvPr>
-        </p:nvSpPr>
-        <p:spPr>
-          <a:xfrm>
-            <a:off x="0" y="8685213"/>
-            <a:ext cx="2971800" cy="458787"/>
-          </a:xfrm>
-          <a:prstGeom prst="rect">
-            <a:avLst/>
-          </a:prstGeom>
-        </p:spPr>
-        <p:txBody>
-          <a:bodyPr vert="horz" lIns="91440" tIns="45720" rIns="91440" bIns="45720" rtlCol="0" anchor="b"/>
-          <a:lstStyle>
-            <a:lvl1pPr algn="l">
-              <a:defRPr sz="1200"/>
-            </a:lvl1pPr>
-          </a:lstStyle>
-          <a:p>
-            <a:endParaRPr lang="en-US"/>
-          </a:p>
-        </p:txBody>
-      </p:sp>
-      <p:sp>
-        <p:nvSpPr>
-          <p:cNvPr id="7" name="Slide Number Placeholder 6"/>
-          <p:cNvSpPr>
-            <a:spLocks noGrp="1"/>
-          </p:cNvSpPr>
-          <p:nvPr>
-            <p:ph type="sldNum" sz="quarter" idx="5"/>
-          </p:nvPr>
-        </p:nvSpPr>
-        <p:spPr>
-          <a:xfrm>
-            <a:off x="3884613" y="8685213"/>
-            <a:ext cx="2971800" cy="458787"/>
-          </a:xfrm>
-          <a:prstGeom prst="rect">
-            <a:avLst/>
-          </a:prstGeom>
-        </p:spPr>
-        <p:txBody>
-          <a:bodyPr vert="horz" lIns="91440" tIns="45720" rIns="91440" bIns="45720" rtlCol="0" anchor="b"/>
-          <a:lstStyle>
-            <a:lvl1pPr algn="r">
-              <a:defRPr sz="1200"/>
-            </a:lvl1pPr>
-          </a:lstStyle>
-          <a:p>
-            <a:fld id="{CE5E9CC1-C706-0F49-92D6-E571CC5EEA8F}" type="slidenum">
-              <a:rPr lang="en-US"/>
-              <a:t>‹#›</a:t>
-            </a:fld>
-            <a:endParaRPr lang="en-US"/>
-          </a:p>
-        </p:txBody>
-      </p:sp>
     </p:spTree>
     <p:extLst>
       <p:ext uri="{BB962C8B-B14F-4D97-AF65-F5344CB8AC3E}">
-        <p14:creationId xmlns:p14="http://schemas.microsoft.com/office/powerpoint/2010/main" val="1024086991"/>
+        <p14:creationId xmlns:p14="http://schemas.microsoft.com/office/powerpoint/2010/main" val="2201085148"/>
       </p:ext>
     </p:extLst>
   </p:cSld>
@@ -1040,10 +723,6 @@
           <a:bodyPr/>
           <a:lstStyle/>
           <a:p>
-            <a:r>
-              <a:rPr lang="en-US" dirty="0"/>
-              <a:t/>
-            </a:r>
             <a:endParaRPr lang="en-US" dirty="0"/>
           </a:p>
         </p:txBody>
@@ -1128,10 +807,6 @@
           <a:bodyPr/>
           <a:lstStyle/>
           <a:p>
-            <a:r>
-              <a:rPr lang="en-US" dirty="0"/>
-              <a:t/>
-            </a:r>
             <a:endParaRPr lang="en-US" dirty="0"/>
           </a:p>
         </p:txBody>
@@ -1216,10 +891,6 @@
           <a:bodyPr/>
           <a:lstStyle/>
           <a:p>
-            <a:r>
-              <a:rPr lang="en-US" dirty="0"/>
-              <a:t/>
-            </a:r>
             <a:endParaRPr lang="en-US" dirty="0"/>
           </a:p>
         </p:txBody>
@@ -1304,10 +975,6 @@
           <a:bodyPr/>
           <a:lstStyle/>
           <a:p>
-            <a:r>
-              <a:rPr lang="en-US" dirty="0"/>
-              <a:t/>
-            </a:r>
             <a:endParaRPr lang="en-US" dirty="0"/>
           </a:p>
         </p:txBody>
@@ -1392,10 +1059,6 @@
           <a:bodyPr/>
           <a:lstStyle/>
           <a:p>
-            <a:r>
-              <a:rPr lang="en-US" dirty="0"/>
-              <a:t/>
-            </a:r>
             <a:endParaRPr lang="en-US" dirty="0"/>
           </a:p>
         </p:txBody>
@@ -1480,10 +1143,6 @@
           <a:bodyPr/>
           <a:lstStyle/>
           <a:p>
-            <a:r>
-              <a:rPr lang="en-US" dirty="0"/>
-              <a:t/>
-            </a:r>
             <a:endParaRPr lang="en-US" dirty="0"/>
           </a:p>
         </p:txBody>
@@ -1568,10 +1227,6 @@
           <a:bodyPr/>
           <a:lstStyle/>
           <a:p>
-            <a:r>
-              <a:rPr lang="en-US" dirty="0"/>
-              <a:t/>
-            </a:r>
             <a:endParaRPr lang="en-US" dirty="0"/>
           </a:p>
         </p:txBody>
@@ -1656,10 +1311,6 @@
           <a:bodyPr/>
           <a:lstStyle/>
           <a:p>
-            <a:r>
-              <a:rPr lang="en-US" dirty="0"/>
-              <a:t/>
-            </a:r>
             <a:endParaRPr lang="en-US" dirty="0"/>
           </a:p>
         </p:txBody>
@@ -1744,10 +1395,6 @@
           <a:bodyPr/>
           <a:lstStyle/>
           <a:p>
-            <a:r>
-              <a:rPr lang="en-US" dirty="0"/>
-              <a:t/>
-            </a:r>
             <a:endParaRPr lang="en-US" dirty="0"/>
           </a:p>
         </p:txBody>
@@ -1832,10 +1479,6 @@
           <a:bodyPr/>
           <a:lstStyle/>
           <a:p>
-            <a:r>
-              <a:rPr lang="en-US" dirty="0"/>
-              <a:t/>
-            </a:r>
             <a:endParaRPr lang="en-US" dirty="0"/>
           </a:p>
         </p:txBody>
@@ -1909,6 +1552,11 @@
 <file path=ppt/slideMasters/slideMaster1.xml><?xml version="1.0" encoding="utf-8"?>
 <p:sldMaster xmlns:a="http://schemas.openxmlformats.org/drawingml/2006/main" xmlns:r="http://schemas.openxmlformats.org/officeDocument/2006/relationships" xmlns:p="http://schemas.openxmlformats.org/presentationml/2006/main">
   <p:cSld>
+    <p:bg>
+      <p:bgRef idx="1001">
+        <a:schemeClr val="bg1"/>
+      </p:bgRef>
+    </p:bg>
     <p:spTree>
       <p:nvGrpSpPr>
         <p:cNvPr id="1" name=""/>
@@ -2191,6 +1839,7 @@
         <a:solidFill>
           <a:srgbClr val="1B4332"/>
         </a:solidFill>
+        <a:effectLst/>
       </p:bgPr>
     </p:bg>
     <p:spTree>
@@ -2228,6 +1877,13 @@
             <a:prstDash val="solid"/>
           </a:ln>
         </p:spPr>
+        <p:txBody>
+          <a:bodyPr/>
+          <a:lstStyle/>
+          <a:p>
+            <a:endParaRPr lang="it-IT"/>
+          </a:p>
+        </p:txBody>
       </p:sp>
       <p:sp>
         <p:nvSpPr>
@@ -2250,6 +1906,13 @@
             <a:prstDash val="solid"/>
           </a:ln>
         </p:spPr>
+        <p:txBody>
+          <a:bodyPr/>
+          <a:lstStyle/>
+          <a:p>
+            <a:endParaRPr lang="it-IT"/>
+          </a:p>
+        </p:txBody>
       </p:sp>
       <p:sp>
         <p:nvSpPr>
@@ -2273,6 +1936,13 @@
             <a:prstDash val="solid"/>
           </a:ln>
         </p:spPr>
+        <p:txBody>
+          <a:bodyPr/>
+          <a:lstStyle/>
+          <a:p>
+            <a:endParaRPr lang="it-IT"/>
+          </a:p>
+        </p:txBody>
       </p:sp>
       <p:sp>
         <p:nvSpPr>
@@ -2295,7 +1965,7 @@
           <a:bodyPr wrap="square" lIns="0" tIns="0" rIns="0" bIns="0" rtlCol="0" anchor="ctr"/>
           <a:lstStyle/>
           <a:p>
-            <a:pPr indent="0" marL="0">
+            <a:pPr marL="0" indent="0">
               <a:buNone/>
             </a:pPr>
             <a:r>
@@ -2334,7 +2004,7 @@
           <a:bodyPr wrap="square" lIns="0" tIns="0" rIns="0" bIns="0" rtlCol="0" anchor="ctr"/>
           <a:lstStyle/>
           <a:p>
-            <a:pPr indent="0" marL="0">
+            <a:pPr marL="0" indent="0">
               <a:buNone/>
             </a:pPr>
             <a:r>
@@ -2373,7 +2043,7 @@
           <a:bodyPr wrap="square" lIns="0" tIns="0" rIns="0" bIns="0" rtlCol="0" anchor="ctr"/>
           <a:lstStyle/>
           <a:p>
-            <a:pPr indent="0" marL="0">
+            <a:pPr marL="0" indent="0">
               <a:buNone/>
             </a:pPr>
             <a:r>
@@ -2387,9 +2057,6 @@
               </a:rPr>
               <a:t>Live demo:  </a:t>
             </a:r>
-            <a:pPr indent="0" marL="0">
-              <a:buNone/>
-            </a:pPr>
             <a:r>
               <a:rPr lang="en-US" sz="1500" dirty="0">
                 <a:solidFill>
@@ -2426,7 +2093,7 @@
           <a:bodyPr wrap="square" lIns="0" tIns="0" rIns="0" bIns="0" rtlCol="0" anchor="ctr"/>
           <a:lstStyle/>
           <a:p>
-            <a:pPr indent="0" marL="0">
+            <a:pPr marL="0" indent="0">
               <a:buNone/>
             </a:pPr>
             <a:r>
@@ -2438,7 +2105,51 @@
                 <a:ea typeface="Calibri" pitchFamily="34" charset="-122"/>
                 <a:cs typeface="Calibri" pitchFamily="34" charset="-120"/>
               </a:rPr>
-              <a:t>Harish Bhavandla  ·  NLP with LLMs — Final Project  ·  June 2026</a:t>
+              <a:t>Harish </a:t>
+            </a:r>
+            <a:r>
+              <a:rPr lang="en-US" sz="1200" dirty="0" err="1">
+                <a:solidFill>
+                  <a:srgbClr val="95D5B2"/>
+                </a:solidFill>
+                <a:latin typeface="Calibri" pitchFamily="34" charset="0"/>
+                <a:ea typeface="Calibri" pitchFamily="34" charset="-122"/>
+                <a:cs typeface="Calibri" pitchFamily="34" charset="-120"/>
+              </a:rPr>
+              <a:t>Bhavandla</a:t>
+            </a:r>
+            <a:r>
+              <a:rPr lang="en-US" sz="1200" dirty="0">
+                <a:solidFill>
+                  <a:srgbClr val="95D5B2"/>
+                </a:solidFill>
+                <a:latin typeface="Calibri" pitchFamily="34" charset="0"/>
+                <a:ea typeface="Calibri" pitchFamily="34" charset="-122"/>
+                <a:cs typeface="Calibri" pitchFamily="34" charset="-120"/>
+              </a:rPr>
+              <a:t>, Virginia Spolaore, </a:t>
+            </a:r>
+            <a:r>
+              <a:rPr lang="en-US" sz="1200">
+                <a:solidFill>
+                  <a:srgbClr val="95D5B2"/>
+                </a:solidFill>
+                <a:latin typeface="Calibri" pitchFamily="34" charset="0"/>
+                <a:ea typeface="Calibri" pitchFamily="34" charset="-122"/>
+                <a:cs typeface="Calibri" pitchFamily="34" charset="-120"/>
+              </a:rPr>
+              <a:t>Eren Yon  </a:t>
+            </a:r>
+            <a:r>
+              <a:rPr lang="en-US" sz="1200" dirty="0">
+                <a:solidFill>
+                  <a:srgbClr val="95D5B2"/>
+                </a:solidFill>
+                <a:latin typeface="Calibri" pitchFamily="34" charset="0"/>
+                <a:ea typeface="Calibri" pitchFamily="34" charset="-122"/>
+                <a:cs typeface="Calibri" pitchFamily="34" charset="-120"/>
+              </a:rPr>
+              <a:t>·  NLP with LLMs — Final Project  ·  June 2026</a:t>
             </a:r>
             <a:endParaRPr lang="en-US" sz="1200" dirty="0"/>
           </a:p>
@@ -2460,6 +2171,7 @@
         <a:solidFill>
           <a:srgbClr val="1B4332"/>
         </a:solidFill>
+        <a:effectLst/>
       </p:bgPr>
     </p:bg>
     <p:spTree>
@@ -2498,6 +2210,13 @@
             <a:prstDash val="solid"/>
           </a:ln>
         </p:spPr>
+        <p:txBody>
+          <a:bodyPr/>
+          <a:lstStyle/>
+          <a:p>
+            <a:endParaRPr lang="it-IT"/>
+          </a:p>
+        </p:txBody>
       </p:sp>
       <p:sp>
         <p:nvSpPr>
@@ -2520,7 +2239,7 @@
           <a:bodyPr wrap="square" lIns="0" tIns="0" rIns="0" bIns="0" rtlCol="0" anchor="ctr"/>
           <a:lstStyle/>
           <a:p>
-            <a:pPr indent="0" marL="0">
+            <a:pPr marL="0" indent="0">
               <a:buNone/>
             </a:pPr>
             <a:r>
@@ -2665,9 +2384,6 @@
           <a:bodyPr wrap="square" lIns="0" tIns="0" rIns="0" bIns="0" rtlCol="0" anchor="ctr"/>
           <a:lstStyle/>
           <a:p>
-            <a:pPr indent="0" marL="0">
-              <a:buNone/>
-            </a:pPr>
             <a:r>
               <a:rPr lang="en-US" sz="1300" b="1" dirty="0">
                 <a:solidFill>
@@ -2679,9 +2395,17 @@
               </a:rPr>
               <a:t>Demo  </a:t>
             </a:r>
-            <a:pPr indent="0" marL="0">
-              <a:buNone/>
-            </a:pPr>
+            <a:r>
+              <a:rPr lang="en-US" sz="1300" dirty="0" err="1">
+                <a:solidFill>
+                  <a:srgbClr val="FFFFFF"/>
+                </a:solidFill>
+                <a:latin typeface="Calibri" pitchFamily="34" charset="0"/>
+                <a:ea typeface="Calibri" pitchFamily="34" charset="-122"/>
+                <a:cs typeface="Calibri" pitchFamily="34" charset="-120"/>
+              </a:rPr>
+              <a:t>fifa-rag.vercel.app</a:t>
+            </a:r>
             <a:r>
               <a:rPr lang="en-US" sz="1300" dirty="0">
                 <a:solidFill>
@@ -2691,11 +2415,8 @@
                 <a:ea typeface="Calibri" pitchFamily="34" charset="-122"/>
                 <a:cs typeface="Calibri" pitchFamily="34" charset="-120"/>
               </a:rPr>
-              <a:t>fifa-rag.vercel.app      </a:t>
-            </a:r>
-            <a:pPr indent="0" marL="0">
-              <a:buNone/>
-            </a:pPr>
+              <a:t>      </a:t>
+            </a:r>
             <a:r>
               <a:rPr lang="en-US" sz="1300" b="1" dirty="0">
                 <a:solidFill>
@@ -2705,23 +2426,21 @@
                 <a:ea typeface="Calibri" pitchFamily="34" charset="-122"/>
                 <a:cs typeface="Calibri" pitchFamily="34" charset="-120"/>
               </a:rPr>
-              <a:t>Repo  </a:t>
-            </a:r>
-            <a:pPr indent="0" marL="0">
-              <a:buNone/>
-            </a:pPr>
-            <a:r>
-              <a:rPr lang="en-US" sz="1300" dirty="0">
-                <a:solidFill>
-                  <a:srgbClr val="FFFFFF"/>
-                </a:solidFill>
-                <a:latin typeface="Calibri" pitchFamily="34" charset="0"/>
-                <a:ea typeface="Calibri" pitchFamily="34" charset="-122"/>
-                <a:cs typeface="Calibri" pitchFamily="34" charset="-120"/>
-              </a:rPr>
-              <a:t>github.com/harishbhavandla/fifa-rag-chatbot</a:t>
-            </a:r>
-            <a:endParaRPr lang="en-US" sz="1300" dirty="0"/>
+              <a:t>Repo </a:t>
+            </a:r>
+            <a:r>
+              <a:rPr lang="it-IT" sz="1400" dirty="0">
+                <a:solidFill>
+                  <a:schemeClr val="bg1"/>
+                </a:solidFill>
+              </a:rPr>
+              <a:t>github.com/harish885/fifa-rag-chatbot</a:t>
+            </a:r>
+            <a:endParaRPr lang="en-US" sz="1300" dirty="0">
+              <a:solidFill>
+                <a:schemeClr val="bg1"/>
+              </a:solidFill>
+            </a:endParaRPr>
           </a:p>
         </p:txBody>
       </p:sp>
@@ -2746,7 +2465,7 @@
           <a:bodyPr wrap="square" lIns="0" tIns="0" rIns="0" bIns="0" rtlCol="0" anchor="ctr"/>
           <a:lstStyle/>
           <a:p>
-            <a:pPr indent="0" marL="0">
+            <a:pPr marL="0" indent="0">
               <a:buNone/>
             </a:pPr>
             <a:r>
@@ -2780,6 +2499,7 @@
         <a:solidFill>
           <a:srgbClr val="F7F9F4"/>
         </a:solidFill>
+        <a:effectLst/>
       </p:bgPr>
     </p:bg>
     <p:spTree>
@@ -2817,7 +2537,7 @@
           <a:bodyPr wrap="square" lIns="0" tIns="0" rIns="0" bIns="0" rtlCol="0" anchor="ctr"/>
           <a:lstStyle/>
           <a:p>
-            <a:pPr indent="0" marL="0">
+            <a:pPr marL="0" indent="0">
               <a:buNone/>
             </a:pPr>
             <a:r>
@@ -2859,13 +2579,20 @@
             <a:prstDash val="solid"/>
           </a:ln>
           <a:effectLst>
-            <a:outerShdw sx="100000" sy="100000" kx="0" ky="0" algn="bl" rotWithShape="0" blurRad="76200" dist="25400" dir="8100000">
+            <a:outerShdw blurRad="76200" dist="25400" dir="8100000" algn="bl" rotWithShape="0">
               <a:srgbClr val="000000">
                 <a:alpha val="12000"/>
               </a:srgbClr>
             </a:outerShdw>
           </a:effectLst>
         </p:spPr>
+        <p:txBody>
+          <a:bodyPr/>
+          <a:lstStyle/>
+          <a:p>
+            <a:endParaRPr lang="it-IT"/>
+          </a:p>
+        </p:txBody>
       </p:sp>
       <p:sp>
         <p:nvSpPr>
@@ -2888,7 +2615,7 @@
           <a:bodyPr wrap="square" lIns="0" tIns="0" rIns="0" bIns="0" rtlCol="0" anchor="ctr"/>
           <a:lstStyle/>
           <a:p>
-            <a:pPr algn="ctr" indent="0" marL="0">
+            <a:pPr marL="0" indent="0" algn="ctr">
               <a:buNone/>
             </a:pPr>
             <a:r>
@@ -2927,7 +2654,7 @@
           <a:bodyPr wrap="square" lIns="0" tIns="0" rIns="0" bIns="0" rtlCol="0" anchor="ctr"/>
           <a:lstStyle/>
           <a:p>
-            <a:pPr algn="ctr" indent="0" marL="0">
+            <a:pPr marL="0" indent="0" algn="ctr">
               <a:buNone/>
             </a:pPr>
             <a:r>
@@ -2969,13 +2696,20 @@
             <a:prstDash val="solid"/>
           </a:ln>
           <a:effectLst>
-            <a:outerShdw sx="100000" sy="100000" kx="0" ky="0" algn="bl" rotWithShape="0" blurRad="76200" dist="25400" dir="8100000">
+            <a:outerShdw blurRad="76200" dist="25400" dir="8100000" algn="bl" rotWithShape="0">
               <a:srgbClr val="000000">
                 <a:alpha val="12000"/>
               </a:srgbClr>
             </a:outerShdw>
           </a:effectLst>
         </p:spPr>
+        <p:txBody>
+          <a:bodyPr/>
+          <a:lstStyle/>
+          <a:p>
+            <a:endParaRPr lang="it-IT"/>
+          </a:p>
+        </p:txBody>
       </p:sp>
       <p:sp>
         <p:nvSpPr>
@@ -2998,7 +2732,7 @@
           <a:bodyPr wrap="square" lIns="0" tIns="0" rIns="0" bIns="0" rtlCol="0" anchor="ctr"/>
           <a:lstStyle/>
           <a:p>
-            <a:pPr algn="ctr" indent="0" marL="0">
+            <a:pPr marL="0" indent="0" algn="ctr">
               <a:buNone/>
             </a:pPr>
             <a:r>
@@ -3037,7 +2771,7 @@
           <a:bodyPr wrap="square" lIns="0" tIns="0" rIns="0" bIns="0" rtlCol="0" anchor="ctr"/>
           <a:lstStyle/>
           <a:p>
-            <a:pPr algn="ctr" indent="0" marL="0">
+            <a:pPr marL="0" indent="0" algn="ctr">
               <a:buNone/>
             </a:pPr>
             <a:r>
@@ -3079,13 +2813,20 @@
             <a:prstDash val="solid"/>
           </a:ln>
           <a:effectLst>
-            <a:outerShdw sx="100000" sy="100000" kx="0" ky="0" algn="bl" rotWithShape="0" blurRad="76200" dist="25400" dir="8100000">
+            <a:outerShdw blurRad="76200" dist="25400" dir="8100000" algn="bl" rotWithShape="0">
               <a:srgbClr val="000000">
                 <a:alpha val="12000"/>
               </a:srgbClr>
             </a:outerShdw>
           </a:effectLst>
         </p:spPr>
+        <p:txBody>
+          <a:bodyPr/>
+          <a:lstStyle/>
+          <a:p>
+            <a:endParaRPr lang="it-IT"/>
+          </a:p>
+        </p:txBody>
       </p:sp>
       <p:sp>
         <p:nvSpPr>
@@ -3108,7 +2849,7 @@
           <a:bodyPr wrap="square" lIns="0" tIns="0" rIns="0" bIns="0" rtlCol="0" anchor="ctr"/>
           <a:lstStyle/>
           <a:p>
-            <a:pPr algn="ctr" indent="0" marL="0">
+            <a:pPr marL="0" indent="0" algn="ctr">
               <a:buNone/>
             </a:pPr>
             <a:r>
@@ -3147,7 +2888,7 @@
           <a:bodyPr wrap="square" lIns="0" tIns="0" rIns="0" bIns="0" rtlCol="0" anchor="ctr"/>
           <a:lstStyle/>
           <a:p>
-            <a:pPr algn="ctr" indent="0" marL="0">
+            <a:pPr marL="0" indent="0" algn="ctr">
               <a:buNone/>
             </a:pPr>
             <a:r>
@@ -3186,7 +2927,7 @@
           <a:bodyPr wrap="square" lIns="0" tIns="0" rIns="0" bIns="0" rtlCol="0" anchor="ctr"/>
           <a:lstStyle/>
           <a:p>
-            <a:pPr indent="0" marL="0">
+            <a:pPr marL="0" indent="0">
               <a:buNone/>
             </a:pPr>
             <a:r>
@@ -3200,9 +2941,6 @@
               </a:rPr>
               <a:t>Goal. </a:t>
             </a:r>
-            <a:pPr indent="0" marL="0">
-              <a:buNone/>
-            </a:pPr>
             <a:r>
               <a:rPr lang="en-US" sz="1400" dirty="0">
                 <a:solidFill>
@@ -3239,7 +2977,7 @@
           <a:bodyPr wrap="square" lIns="0" tIns="0" rIns="0" bIns="0" rtlCol="0" anchor="ctr"/>
           <a:lstStyle/>
           <a:p>
-            <a:pPr indent="0" marL="0">
+            <a:pPr marL="0" indent="0">
               <a:buNone/>
             </a:pPr>
             <a:r>
@@ -3253,9 +2991,6 @@
               </a:rPr>
               <a:t>The core NLP difficulty — the register gap.  </a:t>
             </a:r>
-            <a:pPr indent="0" marL="0">
-              <a:buNone/>
-            </a:pPr>
             <a:r>
               <a:rPr lang="en-US" sz="1400" dirty="0">
                 <a:solidFill>
@@ -3292,7 +3027,7 @@
           <a:bodyPr wrap="square" rtlCol="0" anchor="ctr"/>
           <a:lstStyle/>
           <a:p>
-            <a:pPr indent="0" marL="0">
+            <a:pPr marL="0" indent="0">
               <a:buNone/>
             </a:pPr>
             <a:r>
@@ -3326,6 +3061,7 @@
         <a:solidFill>
           <a:srgbClr val="F7F9F4"/>
         </a:solidFill>
+        <a:effectLst/>
       </p:bgPr>
     </p:bg>
     <p:spTree>
@@ -3363,7 +3099,7 @@
           <a:bodyPr wrap="square" lIns="0" tIns="0" rIns="0" bIns="0" rtlCol="0" anchor="ctr"/>
           <a:lstStyle/>
           <a:p>
-            <a:pPr indent="0" marL="0">
+            <a:pPr marL="0" indent="0">
               <a:buNone/>
             </a:pPr>
             <a:r>
@@ -3402,11 +3138,11 @@
           <a:bodyPr wrap="square" lIns="0" tIns="0" rIns="0" bIns="0" rtlCol="0" anchor="ctr"/>
           <a:lstStyle/>
           <a:p>
-            <a:pPr indent="0" marL="0">
-              <a:buNone/>
-            </a:pPr>
-            <a:r>
-              <a:rPr lang="en-US" sz="1050" b="1" spc="200" kern="0" dirty="0">
+            <a:pPr marL="0" indent="0">
+              <a:buNone/>
+            </a:pPr>
+            <a:r>
+              <a:rPr lang="en-US" sz="1050" b="1" kern="0" spc="200" dirty="0">
                 <a:solidFill>
                   <a:srgbClr val="5C6F65"/>
                 </a:solidFill>
@@ -3444,13 +3180,20 @@
             <a:prstDash val="solid"/>
           </a:ln>
           <a:effectLst>
-            <a:outerShdw sx="100000" sy="100000" kx="0" ky="0" algn="bl" rotWithShape="0" blurRad="63500" dist="25400" dir="8100000">
+            <a:outerShdw blurRad="63500" dist="25400" dir="8100000" algn="bl" rotWithShape="0">
               <a:srgbClr val="000000">
                 <a:alpha val="12000"/>
               </a:srgbClr>
             </a:outerShdw>
           </a:effectLst>
         </p:spPr>
+        <p:txBody>
+          <a:bodyPr/>
+          <a:lstStyle/>
+          <a:p>
+            <a:endParaRPr lang="it-IT"/>
+          </a:p>
+        </p:txBody>
       </p:sp>
       <p:sp>
         <p:nvSpPr>
@@ -3473,7 +3216,7 @@
           <a:bodyPr wrap="square" lIns="0" tIns="0" rIns="0" bIns="0" rtlCol="0" anchor="ctr"/>
           <a:lstStyle/>
           <a:p>
-            <a:pPr indent="0" marL="0">
+            <a:pPr marL="0" indent="0">
               <a:buNone/>
             </a:pPr>
             <a:r>
@@ -3512,7 +3255,7 @@
           <a:bodyPr wrap="square" lIns="0" tIns="0" rIns="0" bIns="0" rtlCol="0" anchor="ctr"/>
           <a:lstStyle/>
           <a:p>
-            <a:pPr indent="0" marL="0">
+            <a:pPr marL="0" indent="0">
               <a:buNone/>
             </a:pPr>
             <a:r>
@@ -3553,6 +3296,13 @@
             <a:tailEnd type="triangle"/>
           </a:ln>
         </p:spPr>
+        <p:txBody>
+          <a:bodyPr/>
+          <a:lstStyle/>
+          <a:p>
+            <a:endParaRPr lang="it-IT"/>
+          </a:p>
+        </p:txBody>
       </p:sp>
       <p:sp>
         <p:nvSpPr>
@@ -3578,13 +3328,20 @@
             <a:prstDash val="solid"/>
           </a:ln>
           <a:effectLst>
-            <a:outerShdw sx="100000" sy="100000" kx="0" ky="0" algn="bl" rotWithShape="0" blurRad="63500" dist="25400" dir="8100000">
+            <a:outerShdw blurRad="63500" dist="25400" dir="8100000" algn="bl" rotWithShape="0">
               <a:srgbClr val="000000">
                 <a:alpha val="12000"/>
               </a:srgbClr>
             </a:outerShdw>
           </a:effectLst>
         </p:spPr>
+        <p:txBody>
+          <a:bodyPr/>
+          <a:lstStyle/>
+          <a:p>
+            <a:endParaRPr lang="it-IT"/>
+          </a:p>
+        </p:txBody>
       </p:sp>
       <p:sp>
         <p:nvSpPr>
@@ -3607,7 +3364,7 @@
           <a:bodyPr wrap="square" lIns="0" tIns="0" rIns="0" bIns="0" rtlCol="0" anchor="ctr"/>
           <a:lstStyle/>
           <a:p>
-            <a:pPr indent="0" marL="0">
+            <a:pPr marL="0" indent="0">
               <a:buNone/>
             </a:pPr>
             <a:r>
@@ -3646,7 +3403,7 @@
           <a:bodyPr wrap="square" lIns="0" tIns="0" rIns="0" bIns="0" rtlCol="0" anchor="ctr"/>
           <a:lstStyle/>
           <a:p>
-            <a:pPr indent="0" marL="0">
+            <a:pPr marL="0" indent="0">
               <a:buNone/>
             </a:pPr>
             <a:r>
@@ -3687,6 +3444,13 @@
             <a:tailEnd type="triangle"/>
           </a:ln>
         </p:spPr>
+        <p:txBody>
+          <a:bodyPr/>
+          <a:lstStyle/>
+          <a:p>
+            <a:endParaRPr lang="it-IT"/>
+          </a:p>
+        </p:txBody>
       </p:sp>
       <p:sp>
         <p:nvSpPr>
@@ -3712,13 +3476,20 @@
             <a:prstDash val="solid"/>
           </a:ln>
           <a:effectLst>
-            <a:outerShdw sx="100000" sy="100000" kx="0" ky="0" algn="bl" rotWithShape="0" blurRad="63500" dist="25400" dir="8100000">
+            <a:outerShdw blurRad="63500" dist="25400" dir="8100000" algn="bl" rotWithShape="0">
               <a:srgbClr val="000000">
                 <a:alpha val="12000"/>
               </a:srgbClr>
             </a:outerShdw>
           </a:effectLst>
         </p:spPr>
+        <p:txBody>
+          <a:bodyPr/>
+          <a:lstStyle/>
+          <a:p>
+            <a:endParaRPr lang="it-IT"/>
+          </a:p>
+        </p:txBody>
       </p:sp>
       <p:sp>
         <p:nvSpPr>
@@ -3741,7 +3512,7 @@
           <a:bodyPr wrap="square" lIns="0" tIns="0" rIns="0" bIns="0" rtlCol="0" anchor="ctr"/>
           <a:lstStyle/>
           <a:p>
-            <a:pPr indent="0" marL="0">
+            <a:pPr marL="0" indent="0">
               <a:buNone/>
             </a:pPr>
             <a:r>
@@ -3780,7 +3551,7 @@
           <a:bodyPr wrap="square" lIns="0" tIns="0" rIns="0" bIns="0" rtlCol="0" anchor="ctr"/>
           <a:lstStyle/>
           <a:p>
-            <a:pPr indent="0" marL="0">
+            <a:pPr marL="0" indent="0">
               <a:buNone/>
             </a:pPr>
             <a:r>
@@ -3819,11 +3590,11 @@
           <a:bodyPr wrap="square" lIns="0" tIns="0" rIns="0" bIns="0" rtlCol="0" anchor="ctr"/>
           <a:lstStyle/>
           <a:p>
-            <a:pPr indent="0" marL="0">
-              <a:buNone/>
-            </a:pPr>
-            <a:r>
-              <a:rPr lang="en-US" sz="1050" b="1" spc="200" kern="0" dirty="0">
+            <a:pPr marL="0" indent="0">
+              <a:buNone/>
+            </a:pPr>
+            <a:r>
+              <a:rPr lang="en-US" sz="1050" b="1" kern="0" spc="200" dirty="0">
                 <a:solidFill>
                   <a:srgbClr val="5C6F65"/>
                 </a:solidFill>
@@ -3861,13 +3632,20 @@
             <a:prstDash val="solid"/>
           </a:ln>
           <a:effectLst>
-            <a:outerShdw sx="100000" sy="100000" kx="0" ky="0" algn="bl" rotWithShape="0" blurRad="63500" dist="25400" dir="8100000">
+            <a:outerShdw blurRad="63500" dist="25400" dir="8100000" algn="bl" rotWithShape="0">
               <a:srgbClr val="000000">
                 <a:alpha val="12000"/>
               </a:srgbClr>
             </a:outerShdw>
           </a:effectLst>
         </p:spPr>
+        <p:txBody>
+          <a:bodyPr/>
+          <a:lstStyle/>
+          <a:p>
+            <a:endParaRPr lang="it-IT"/>
+          </a:p>
+        </p:txBody>
       </p:sp>
       <p:sp>
         <p:nvSpPr>
@@ -3890,7 +3668,7 @@
           <a:bodyPr wrap="square" lIns="0" tIns="0" rIns="0" bIns="0" rtlCol="0" anchor="ctr"/>
           <a:lstStyle/>
           <a:p>
-            <a:pPr indent="0" marL="0">
+            <a:pPr marL="0" indent="0">
               <a:buNone/>
             </a:pPr>
             <a:r>
@@ -3929,7 +3707,7 @@
           <a:bodyPr wrap="square" lIns="0" tIns="0" rIns="0" bIns="0" rtlCol="0" anchor="ctr"/>
           <a:lstStyle/>
           <a:p>
-            <a:pPr indent="0" marL="0">
+            <a:pPr marL="0" indent="0">
               <a:buNone/>
             </a:pPr>
             <a:r>
@@ -3970,6 +3748,13 @@
             <a:tailEnd type="triangle"/>
           </a:ln>
         </p:spPr>
+        <p:txBody>
+          <a:bodyPr/>
+          <a:lstStyle/>
+          <a:p>
+            <a:endParaRPr lang="it-IT"/>
+          </a:p>
+        </p:txBody>
       </p:sp>
       <p:sp>
         <p:nvSpPr>
@@ -3995,13 +3780,20 @@
             <a:prstDash val="solid"/>
           </a:ln>
           <a:effectLst>
-            <a:outerShdw sx="100000" sy="100000" kx="0" ky="0" algn="bl" rotWithShape="0" blurRad="63500" dist="25400" dir="8100000">
+            <a:outerShdw blurRad="63500" dist="25400" dir="8100000" algn="bl" rotWithShape="0">
               <a:srgbClr val="000000">
                 <a:alpha val="12000"/>
               </a:srgbClr>
             </a:outerShdw>
           </a:effectLst>
         </p:spPr>
+        <p:txBody>
+          <a:bodyPr/>
+          <a:lstStyle/>
+          <a:p>
+            <a:endParaRPr lang="it-IT"/>
+          </a:p>
+        </p:txBody>
       </p:sp>
       <p:sp>
         <p:nvSpPr>
@@ -4024,7 +3816,7 @@
           <a:bodyPr wrap="square" lIns="0" tIns="0" rIns="0" bIns="0" rtlCol="0" anchor="ctr"/>
           <a:lstStyle/>
           <a:p>
-            <a:pPr indent="0" marL="0">
+            <a:pPr marL="0" indent="0">
               <a:buNone/>
             </a:pPr>
             <a:r>
@@ -4063,7 +3855,7 @@
           <a:bodyPr wrap="square" lIns="0" tIns="0" rIns="0" bIns="0" rtlCol="0" anchor="ctr"/>
           <a:lstStyle/>
           <a:p>
-            <a:pPr indent="0" marL="0">
+            <a:pPr marL="0" indent="0">
               <a:buNone/>
             </a:pPr>
             <a:r>
@@ -4104,6 +3896,13 @@
             <a:tailEnd type="triangle"/>
           </a:ln>
         </p:spPr>
+        <p:txBody>
+          <a:bodyPr/>
+          <a:lstStyle/>
+          <a:p>
+            <a:endParaRPr lang="it-IT"/>
+          </a:p>
+        </p:txBody>
       </p:sp>
       <p:sp>
         <p:nvSpPr>
@@ -4129,13 +3928,20 @@
             <a:prstDash val="solid"/>
           </a:ln>
           <a:effectLst>
-            <a:outerShdw sx="100000" sy="100000" kx="0" ky="0" algn="bl" rotWithShape="0" blurRad="63500" dist="25400" dir="8100000">
+            <a:outerShdw blurRad="63500" dist="25400" dir="8100000" algn="bl" rotWithShape="0">
               <a:srgbClr val="000000">
                 <a:alpha val="12000"/>
               </a:srgbClr>
             </a:outerShdw>
           </a:effectLst>
         </p:spPr>
+        <p:txBody>
+          <a:bodyPr/>
+          <a:lstStyle/>
+          <a:p>
+            <a:endParaRPr lang="it-IT"/>
+          </a:p>
+        </p:txBody>
       </p:sp>
       <p:sp>
         <p:nvSpPr>
@@ -4158,7 +3964,7 @@
           <a:bodyPr wrap="square" lIns="0" tIns="0" rIns="0" bIns="0" rtlCol="0" anchor="ctr"/>
           <a:lstStyle/>
           <a:p>
-            <a:pPr indent="0" marL="0">
+            <a:pPr marL="0" indent="0">
               <a:buNone/>
             </a:pPr>
             <a:r>
@@ -4197,7 +4003,7 @@
           <a:bodyPr wrap="square" lIns="0" tIns="0" rIns="0" bIns="0" rtlCol="0" anchor="ctr"/>
           <a:lstStyle/>
           <a:p>
-            <a:pPr indent="0" marL="0">
+            <a:pPr marL="0" indent="0">
               <a:buNone/>
             </a:pPr>
             <a:r>
@@ -4238,6 +4044,13 @@
             <a:tailEnd type="triangle"/>
           </a:ln>
         </p:spPr>
+        <p:txBody>
+          <a:bodyPr/>
+          <a:lstStyle/>
+          <a:p>
+            <a:endParaRPr lang="it-IT"/>
+          </a:p>
+        </p:txBody>
       </p:sp>
       <p:sp>
         <p:nvSpPr>
@@ -4263,13 +4076,20 @@
             <a:prstDash val="solid"/>
           </a:ln>
           <a:effectLst>
-            <a:outerShdw sx="100000" sy="100000" kx="0" ky="0" algn="bl" rotWithShape="0" blurRad="63500" dist="25400" dir="8100000">
+            <a:outerShdw blurRad="63500" dist="25400" dir="8100000" algn="bl" rotWithShape="0">
               <a:srgbClr val="000000">
                 <a:alpha val="12000"/>
               </a:srgbClr>
             </a:outerShdw>
           </a:effectLst>
         </p:spPr>
+        <p:txBody>
+          <a:bodyPr/>
+          <a:lstStyle/>
+          <a:p>
+            <a:endParaRPr lang="it-IT"/>
+          </a:p>
+        </p:txBody>
       </p:sp>
       <p:sp>
         <p:nvSpPr>
@@ -4292,7 +4112,7 @@
           <a:bodyPr wrap="square" lIns="0" tIns="0" rIns="0" bIns="0" rtlCol="0" anchor="ctr"/>
           <a:lstStyle/>
           <a:p>
-            <a:pPr indent="0" marL="0">
+            <a:pPr marL="0" indent="0">
               <a:buNone/>
             </a:pPr>
             <a:r>
@@ -4331,7 +4151,7 @@
           <a:bodyPr wrap="square" lIns="0" tIns="0" rIns="0" bIns="0" rtlCol="0" anchor="ctr"/>
           <a:lstStyle/>
           <a:p>
-            <a:pPr indent="0" marL="0">
+            <a:pPr marL="0" indent="0">
               <a:buNone/>
             </a:pPr>
             <a:r>
@@ -4370,7 +4190,7 @@
           <a:bodyPr wrap="square" rtlCol="0" anchor="ctr"/>
           <a:lstStyle/>
           <a:p>
-            <a:pPr indent="0" marL="0">
+            <a:pPr marL="0" indent="0">
               <a:buNone/>
             </a:pPr>
             <a:r>
@@ -4404,6 +4224,7 @@
         <a:solidFill>
           <a:srgbClr val="F7F9F4"/>
         </a:solidFill>
+        <a:effectLst/>
       </p:bgPr>
     </p:bg>
     <p:spTree>
@@ -4441,7 +4262,7 @@
           <a:bodyPr wrap="square" lIns="0" tIns="0" rIns="0" bIns="0" rtlCol="0" anchor="ctr"/>
           <a:lstStyle/>
           <a:p>
-            <a:pPr indent="0" marL="0">
+            <a:pPr marL="0" indent="0">
               <a:buNone/>
             </a:pPr>
             <a:r>
@@ -4483,13 +4304,20 @@
             <a:prstDash val="solid"/>
           </a:ln>
           <a:effectLst>
-            <a:outerShdw sx="100000" sy="100000" kx="0" ky="0" algn="bl" rotWithShape="0" blurRad="63500" dist="25400" dir="8100000">
+            <a:outerShdw blurRad="63500" dist="25400" dir="8100000" algn="bl" rotWithShape="0">
               <a:srgbClr val="000000">
                 <a:alpha val="10000"/>
               </a:srgbClr>
             </a:outerShdw>
           </a:effectLst>
         </p:spPr>
+        <p:txBody>
+          <a:bodyPr/>
+          <a:lstStyle/>
+          <a:p>
+            <a:endParaRPr lang="it-IT"/>
+          </a:p>
+        </p:txBody>
       </p:sp>
       <p:sp>
         <p:nvSpPr>
@@ -4510,6 +4338,13 @@
           </a:solidFill>
           <a:ln/>
         </p:spPr>
+        <p:txBody>
+          <a:bodyPr/>
+          <a:lstStyle/>
+          <a:p>
+            <a:endParaRPr lang="it-IT"/>
+          </a:p>
+        </p:txBody>
       </p:sp>
       <p:sp>
         <p:nvSpPr>
@@ -4532,7 +4367,7 @@
           <a:bodyPr wrap="square" lIns="0" tIns="0" rIns="0" bIns="0" rtlCol="0" anchor="ctr"/>
           <a:lstStyle/>
           <a:p>
-            <a:pPr indent="0" marL="0">
+            <a:pPr marL="0" indent="0">
               <a:buNone/>
             </a:pPr>
             <a:r>
@@ -4571,7 +4406,7 @@
           <a:bodyPr wrap="square" lIns="0" tIns="0" rIns="0" bIns="0" rtlCol="0" anchor="ctr"/>
           <a:lstStyle/>
           <a:p>
-            <a:pPr indent="0" marL="0">
+            <a:pPr marL="0" indent="0">
               <a:buNone/>
             </a:pPr>
             <a:r>
@@ -4613,13 +4448,20 @@
             <a:prstDash val="solid"/>
           </a:ln>
           <a:effectLst>
-            <a:outerShdw sx="100000" sy="100000" kx="0" ky="0" algn="bl" rotWithShape="0" blurRad="63500" dist="25400" dir="8100000">
+            <a:outerShdw blurRad="63500" dist="25400" dir="8100000" algn="bl" rotWithShape="0">
               <a:srgbClr val="000000">
                 <a:alpha val="10000"/>
               </a:srgbClr>
             </a:outerShdw>
           </a:effectLst>
         </p:spPr>
+        <p:txBody>
+          <a:bodyPr/>
+          <a:lstStyle/>
+          <a:p>
+            <a:endParaRPr lang="it-IT"/>
+          </a:p>
+        </p:txBody>
       </p:sp>
       <p:sp>
         <p:nvSpPr>
@@ -4640,6 +4482,13 @@
           </a:solidFill>
           <a:ln/>
         </p:spPr>
+        <p:txBody>
+          <a:bodyPr/>
+          <a:lstStyle/>
+          <a:p>
+            <a:endParaRPr lang="it-IT"/>
+          </a:p>
+        </p:txBody>
       </p:sp>
       <p:sp>
         <p:nvSpPr>
@@ -4662,7 +4511,7 @@
           <a:bodyPr wrap="square" lIns="0" tIns="0" rIns="0" bIns="0" rtlCol="0" anchor="ctr"/>
           <a:lstStyle/>
           <a:p>
-            <a:pPr indent="0" marL="0">
+            <a:pPr marL="0" indent="0">
               <a:buNone/>
             </a:pPr>
             <a:r>
@@ -4701,7 +4550,7 @@
           <a:bodyPr wrap="square" lIns="0" tIns="0" rIns="0" bIns="0" rtlCol="0" anchor="ctr"/>
           <a:lstStyle/>
           <a:p>
-            <a:pPr indent="0" marL="0">
+            <a:pPr marL="0" indent="0">
               <a:buNone/>
             </a:pPr>
             <a:r>
@@ -4743,13 +4592,20 @@
             <a:prstDash val="solid"/>
           </a:ln>
           <a:effectLst>
-            <a:outerShdw sx="100000" sy="100000" kx="0" ky="0" algn="bl" rotWithShape="0" blurRad="63500" dist="25400" dir="8100000">
+            <a:outerShdw blurRad="63500" dist="25400" dir="8100000" algn="bl" rotWithShape="0">
               <a:srgbClr val="000000">
                 <a:alpha val="10000"/>
               </a:srgbClr>
             </a:outerShdw>
           </a:effectLst>
         </p:spPr>
+        <p:txBody>
+          <a:bodyPr/>
+          <a:lstStyle/>
+          <a:p>
+            <a:endParaRPr lang="it-IT"/>
+          </a:p>
+        </p:txBody>
       </p:sp>
       <p:sp>
         <p:nvSpPr>
@@ -4770,6 +4626,13 @@
           </a:solidFill>
           <a:ln/>
         </p:spPr>
+        <p:txBody>
+          <a:bodyPr/>
+          <a:lstStyle/>
+          <a:p>
+            <a:endParaRPr lang="it-IT"/>
+          </a:p>
+        </p:txBody>
       </p:sp>
       <p:sp>
         <p:nvSpPr>
@@ -4792,7 +4655,7 @@
           <a:bodyPr wrap="square" lIns="0" tIns="0" rIns="0" bIns="0" rtlCol="0" anchor="ctr"/>
           <a:lstStyle/>
           <a:p>
-            <a:pPr indent="0" marL="0">
+            <a:pPr marL="0" indent="0">
               <a:buNone/>
             </a:pPr>
             <a:r>
@@ -4831,7 +4694,7 @@
           <a:bodyPr wrap="square" lIns="0" tIns="0" rIns="0" bIns="0" rtlCol="0" anchor="ctr"/>
           <a:lstStyle/>
           <a:p>
-            <a:pPr indent="0" marL="0">
+            <a:pPr marL="0" indent="0">
               <a:buNone/>
             </a:pPr>
             <a:r>
@@ -4873,13 +4736,20 @@
             <a:prstDash val="solid"/>
           </a:ln>
           <a:effectLst>
-            <a:outerShdw sx="100000" sy="100000" kx="0" ky="0" algn="bl" rotWithShape="0" blurRad="63500" dist="25400" dir="8100000">
+            <a:outerShdw blurRad="63500" dist="25400" dir="8100000" algn="bl" rotWithShape="0">
               <a:srgbClr val="000000">
                 <a:alpha val="10000"/>
               </a:srgbClr>
             </a:outerShdw>
           </a:effectLst>
         </p:spPr>
+        <p:txBody>
+          <a:bodyPr/>
+          <a:lstStyle/>
+          <a:p>
+            <a:endParaRPr lang="it-IT"/>
+          </a:p>
+        </p:txBody>
       </p:sp>
       <p:sp>
         <p:nvSpPr>
@@ -4900,6 +4770,13 @@
           </a:solidFill>
           <a:ln/>
         </p:spPr>
+        <p:txBody>
+          <a:bodyPr/>
+          <a:lstStyle/>
+          <a:p>
+            <a:endParaRPr lang="it-IT"/>
+          </a:p>
+        </p:txBody>
       </p:sp>
       <p:sp>
         <p:nvSpPr>
@@ -4922,7 +4799,7 @@
           <a:bodyPr wrap="square" lIns="0" tIns="0" rIns="0" bIns="0" rtlCol="0" anchor="ctr"/>
           <a:lstStyle/>
           <a:p>
-            <a:pPr indent="0" marL="0">
+            <a:pPr marL="0" indent="0">
               <a:buNone/>
             </a:pPr>
             <a:r>
@@ -4961,7 +4838,7 @@
           <a:bodyPr wrap="square" lIns="0" tIns="0" rIns="0" bIns="0" rtlCol="0" anchor="ctr"/>
           <a:lstStyle/>
           <a:p>
-            <a:pPr indent="0" marL="0">
+            <a:pPr marL="0" indent="0">
               <a:buNone/>
             </a:pPr>
             <a:r>
@@ -5000,7 +4877,7 @@
           <a:bodyPr wrap="square" rtlCol="0" anchor="ctr"/>
           <a:lstStyle/>
           <a:p>
-            <a:pPr indent="0" marL="0">
+            <a:pPr marL="0" indent="0">
               <a:buNone/>
             </a:pPr>
             <a:r>
@@ -5034,6 +4911,7 @@
         <a:solidFill>
           <a:srgbClr val="F7F9F4"/>
         </a:solidFill>
+        <a:effectLst/>
       </p:bgPr>
     </p:bg>
     <p:spTree>
@@ -5071,7 +4949,7 @@
           <a:bodyPr wrap="square" lIns="0" tIns="0" rIns="0" bIns="0" rtlCol="0" anchor="ctr"/>
           <a:lstStyle/>
           <a:p>
-            <a:pPr indent="0" marL="0">
+            <a:pPr marL="0" indent="0">
               <a:buNone/>
             </a:pPr>
             <a:r>
@@ -5113,6 +4991,13 @@
             <a:prstDash val="solid"/>
           </a:ln>
         </p:spPr>
+        <p:txBody>
+          <a:bodyPr/>
+          <a:lstStyle/>
+          <a:p>
+            <a:endParaRPr lang="it-IT"/>
+          </a:p>
+        </p:txBody>
       </p:sp>
       <p:sp>
         <p:nvSpPr>
@@ -5133,6 +5018,13 @@
           </a:solidFill>
           <a:ln/>
         </p:spPr>
+        <p:txBody>
+          <a:bodyPr/>
+          <a:lstStyle/>
+          <a:p>
+            <a:endParaRPr lang="it-IT"/>
+          </a:p>
+        </p:txBody>
       </p:sp>
       <p:sp>
         <p:nvSpPr>
@@ -5155,7 +5047,7 @@
           <a:bodyPr wrap="square" lIns="0" tIns="0" rIns="0" bIns="0" rtlCol="0" anchor="ctr"/>
           <a:lstStyle/>
           <a:p>
-            <a:pPr indent="0" marL="0">
+            <a:pPr marL="0" indent="0">
               <a:buNone/>
             </a:pPr>
             <a:r>
@@ -5194,7 +5086,7 @@
           <a:bodyPr wrap="square" lIns="0" tIns="0" rIns="0" bIns="0" rtlCol="0" anchor="ctr"/>
           <a:lstStyle/>
           <a:p>
-            <a:pPr indent="0" marL="0">
+            <a:pPr marL="0" indent="0">
               <a:buNone/>
             </a:pPr>
             <a:r>
@@ -5208,9 +5100,6 @@
               </a:rPr>
               <a:t>Better paraphrase recall in principle, but: embedding model exceeds Vercel's function limit; a hosted vector DB adds cost, latency and ops for a 277-chunk corpus; dense scores are hard to debug.  </a:t>
             </a:r>
-            <a:pPr indent="0" marL="0">
-              <a:buNone/>
-            </a:pPr>
             <a:r>
               <a:rPr lang="en-US" sz="1050" i="1" dirty="0">
                 <a:solidFill>
@@ -5250,6 +5139,13 @@
             <a:prstDash val="solid"/>
           </a:ln>
         </p:spPr>
+        <p:txBody>
+          <a:bodyPr/>
+          <a:lstStyle/>
+          <a:p>
+            <a:endParaRPr lang="it-IT"/>
+          </a:p>
+        </p:txBody>
       </p:sp>
       <p:sp>
         <p:nvSpPr>
@@ -5270,6 +5166,13 @@
           </a:solidFill>
           <a:ln/>
         </p:spPr>
+        <p:txBody>
+          <a:bodyPr/>
+          <a:lstStyle/>
+          <a:p>
+            <a:endParaRPr lang="it-IT"/>
+          </a:p>
+        </p:txBody>
       </p:sp>
       <p:sp>
         <p:nvSpPr>
@@ -5292,7 +5195,7 @@
           <a:bodyPr wrap="square" lIns="0" tIns="0" rIns="0" bIns="0" rtlCol="0" anchor="ctr"/>
           <a:lstStyle/>
           <a:p>
-            <a:pPr indent="0" marL="0">
+            <a:pPr marL="0" indent="0">
               <a:buNone/>
             </a:pPr>
             <a:r>
@@ -5331,7 +5234,7 @@
           <a:bodyPr wrap="square" lIns="0" tIns="0" rIns="0" bIns="0" rtlCol="0" anchor="ctr"/>
           <a:lstStyle/>
           <a:p>
-            <a:pPr indent="0" marL="0">
+            <a:pPr marL="0" indent="0">
               <a:buNone/>
             </a:pPr>
             <a:r>
@@ -5345,9 +5248,6 @@
               </a:rPr>
               <a:t>Expensive; freezes knowledge to one edition of the rules; no citations, so answers are unverifiable.  </a:t>
             </a:r>
-            <a:pPr indent="0" marL="0">
-              <a:buNone/>
-            </a:pPr>
             <a:r>
               <a:rPr lang="en-US" sz="1050" i="1" dirty="0">
                 <a:solidFill>
@@ -5387,6 +5287,13 @@
             <a:prstDash val="solid"/>
           </a:ln>
         </p:spPr>
+        <p:txBody>
+          <a:bodyPr/>
+          <a:lstStyle/>
+          <a:p>
+            <a:endParaRPr lang="it-IT"/>
+          </a:p>
+        </p:txBody>
       </p:sp>
       <p:sp>
         <p:nvSpPr>
@@ -5407,6 +5314,13 @@
           </a:solidFill>
           <a:ln/>
         </p:spPr>
+        <p:txBody>
+          <a:bodyPr/>
+          <a:lstStyle/>
+          <a:p>
+            <a:endParaRPr lang="it-IT"/>
+          </a:p>
+        </p:txBody>
       </p:sp>
       <p:sp>
         <p:nvSpPr>
@@ -5429,7 +5343,7 @@
           <a:bodyPr wrap="square" lIns="0" tIns="0" rIns="0" bIns="0" rtlCol="0" anchor="ctr"/>
           <a:lstStyle/>
           <a:p>
-            <a:pPr indent="0" marL="0">
+            <a:pPr marL="0" indent="0">
               <a:buNone/>
             </a:pPr>
             <a:r>
@@ -5468,7 +5382,7 @@
           <a:bodyPr wrap="square" lIns="0" tIns="0" rIns="0" bIns="0" rtlCol="0" anchor="ctr"/>
           <a:lstStyle/>
           <a:p>
-            <a:pPr indent="0" marL="0">
+            <a:pPr marL="0" indent="0">
               <a:buNone/>
             </a:pPr>
             <a:r>
@@ -5482,9 +5396,6 @@
               </a:rPr>
               <a:t>More latency and cost with no measurable benefit: our evaluation shows the bottleneck is retrieval, not generation.  </a:t>
             </a:r>
-            <a:pPr indent="0" marL="0">
-              <a:buNone/>
-            </a:pPr>
             <a:r>
               <a:rPr lang="en-US" sz="1050" i="1" dirty="0">
                 <a:solidFill>
@@ -5521,7 +5432,7 @@
           <a:bodyPr wrap="square" rtlCol="0" anchor="ctr"/>
           <a:lstStyle/>
           <a:p>
-            <a:pPr indent="0" marL="0">
+            <a:pPr marL="0" indent="0">
               <a:buNone/>
             </a:pPr>
             <a:r>
@@ -5555,6 +5466,7 @@
         <a:solidFill>
           <a:srgbClr val="F7F9F4"/>
         </a:solidFill>
+        <a:effectLst/>
       </p:bgPr>
     </p:bg>
     <p:spTree>
@@ -5592,7 +5504,7 @@
           <a:bodyPr wrap="square" lIns="0" tIns="0" rIns="0" bIns="0" rtlCol="0" anchor="ctr"/>
           <a:lstStyle/>
           <a:p>
-            <a:pPr indent="0" marL="0">
+            <a:pPr marL="0" indent="0">
               <a:buNone/>
             </a:pPr>
             <a:r>
@@ -5629,6 +5541,13 @@
           </a:solidFill>
           <a:ln/>
         </p:spPr>
+        <p:txBody>
+          <a:bodyPr/>
+          <a:lstStyle/>
+          <a:p>
+            <a:endParaRPr lang="it-IT"/>
+          </a:p>
+        </p:txBody>
       </p:sp>
       <p:sp>
         <p:nvSpPr>
@@ -5651,7 +5570,7 @@
           <a:bodyPr wrap="square" lIns="0" tIns="0" rIns="0" bIns="0" rtlCol="0" anchor="ctr"/>
           <a:lstStyle/>
           <a:p>
-            <a:pPr algn="ctr" indent="0" marL="0">
+            <a:pPr marL="0" indent="0" algn="ctr">
               <a:buNone/>
             </a:pPr>
             <a:r>
@@ -5690,7 +5609,7 @@
           <a:bodyPr wrap="square" lIns="0" tIns="0" rIns="0" bIns="0" rtlCol="0" anchor="ctr"/>
           <a:lstStyle/>
           <a:p>
-            <a:pPr indent="0" marL="0">
+            <a:pPr marL="0" indent="0">
               <a:buNone/>
             </a:pPr>
             <a:r>
@@ -5704,9 +5623,6 @@
               </a:rPr>
               <a:t>Gold labels. </a:t>
             </a:r>
-            <a:pPr indent="0" marL="0">
-              <a:buNone/>
-            </a:pPr>
             <a:r>
               <a:rPr lang="en-US" sz="1250" dirty="0">
                 <a:solidFill>
@@ -5741,6 +5657,13 @@
           </a:solidFill>
           <a:ln/>
         </p:spPr>
+        <p:txBody>
+          <a:bodyPr/>
+          <a:lstStyle/>
+          <a:p>
+            <a:endParaRPr lang="it-IT"/>
+          </a:p>
+        </p:txBody>
       </p:sp>
       <p:sp>
         <p:nvSpPr>
@@ -5763,7 +5686,7 @@
           <a:bodyPr wrap="square" lIns="0" tIns="0" rIns="0" bIns="0" rtlCol="0" anchor="ctr"/>
           <a:lstStyle/>
           <a:p>
-            <a:pPr algn="ctr" indent="0" marL="0">
+            <a:pPr marL="0" indent="0" algn="ctr">
               <a:buNone/>
             </a:pPr>
             <a:r>
@@ -5802,7 +5725,7 @@
           <a:bodyPr wrap="square" lIns="0" tIns="0" rIns="0" bIns="0" rtlCol="0" anchor="ctr"/>
           <a:lstStyle/>
           <a:p>
-            <a:pPr indent="0" marL="0">
+            <a:pPr marL="0" indent="0">
               <a:buNone/>
             </a:pPr>
             <a:r>
@@ -5816,9 +5739,6 @@
               </a:rPr>
               <a:t>Metrics. </a:t>
             </a:r>
-            <a:pPr indent="0" marL="0">
-              <a:buNone/>
-            </a:pPr>
             <a:r>
               <a:rPr lang="en-US" sz="1250" dirty="0">
                 <a:solidFill>
@@ -5853,6 +5773,13 @@
           </a:solidFill>
           <a:ln/>
         </p:spPr>
+        <p:txBody>
+          <a:bodyPr/>
+          <a:lstStyle/>
+          <a:p>
+            <a:endParaRPr lang="it-IT"/>
+          </a:p>
+        </p:txBody>
       </p:sp>
       <p:sp>
         <p:nvSpPr>
@@ -5875,7 +5802,7 @@
           <a:bodyPr wrap="square" lIns="0" tIns="0" rIns="0" bIns="0" rtlCol="0" anchor="ctr"/>
           <a:lstStyle/>
           <a:p>
-            <a:pPr algn="ctr" indent="0" marL="0">
+            <a:pPr marL="0" indent="0" algn="ctr">
               <a:buNone/>
             </a:pPr>
             <a:r>
@@ -5914,7 +5841,7 @@
           <a:bodyPr wrap="square" lIns="0" tIns="0" rIns="0" bIns="0" rtlCol="0" anchor="ctr"/>
           <a:lstStyle/>
           <a:p>
-            <a:pPr indent="0" marL="0">
+            <a:pPr marL="0" indent="0">
               <a:buNone/>
             </a:pPr>
             <a:r>
@@ -5928,9 +5855,6 @@
               </a:rPr>
               <a:t>Four systems. </a:t>
             </a:r>
-            <a:pPr indent="0" marL="0">
-              <a:buNone/>
-            </a:pPr>
             <a:r>
               <a:rPr lang="en-US" sz="1250" dirty="0">
                 <a:solidFill>
@@ -5965,6 +5889,13 @@
           </a:solidFill>
           <a:ln/>
         </p:spPr>
+        <p:txBody>
+          <a:bodyPr/>
+          <a:lstStyle/>
+          <a:p>
+            <a:endParaRPr lang="it-IT"/>
+          </a:p>
+        </p:txBody>
       </p:sp>
       <p:sp>
         <p:nvSpPr>
@@ -5987,7 +5918,7 @@
           <a:bodyPr wrap="square" lIns="0" tIns="0" rIns="0" bIns="0" rtlCol="0" anchor="ctr"/>
           <a:lstStyle/>
           <a:p>
-            <a:pPr algn="ctr" indent="0" marL="0">
+            <a:pPr marL="0" indent="0" algn="ctr">
               <a:buNone/>
             </a:pPr>
             <a:r>
@@ -6026,7 +5957,7 @@
           <a:bodyPr wrap="square" lIns="0" tIns="0" rIns="0" bIns="0" rtlCol="0" anchor="ctr"/>
           <a:lstStyle/>
           <a:p>
-            <a:pPr indent="0" marL="0">
+            <a:pPr marL="0" indent="0">
               <a:buNone/>
             </a:pPr>
             <a:r>
@@ -6040,9 +5971,6 @@
               </a:rPr>
               <a:t>Qualitative. </a:t>
             </a:r>
-            <a:pPr indent="0" marL="0">
-              <a:buNone/>
-            </a:pPr>
             <a:r>
               <a:rPr lang="en-US" sz="1250" dirty="0">
                 <a:solidFill>
@@ -6079,7 +6007,7 @@
           <a:bodyPr wrap="square" lIns="0" tIns="0" rIns="0" bIns="0" rtlCol="0" anchor="ctr"/>
           <a:lstStyle/>
           <a:p>
-            <a:pPr indent="0" marL="0">
+            <a:pPr marL="0" indent="0">
               <a:buNone/>
             </a:pPr>
             <a:r>
@@ -6093,9 +6021,6 @@
               </a:rPr>
               <a:t>Fully reproducible offline:  </a:t>
             </a:r>
-            <a:pPr indent="0" marL="0">
-              <a:buNone/>
-            </a:pPr>
             <a:r>
               <a:rPr lang="en-US" sz="1200" dirty="0">
                 <a:solidFill>
@@ -6107,9 +6032,6 @@
               </a:rPr>
               <a:t>python eval/evaluate.py</a:t>
             </a:r>
-            <a:pPr indent="0" marL="0">
-              <a:buNone/>
-            </a:pPr>
             <a:r>
               <a:rPr lang="en-US" sz="1200" dirty="0">
                 <a:solidFill>
@@ -6146,7 +6068,7 @@
           <a:bodyPr wrap="square" rtlCol="0" anchor="ctr"/>
           <a:lstStyle/>
           <a:p>
-            <a:pPr indent="0" marL="0">
+            <a:pPr marL="0" indent="0">
               <a:buNone/>
             </a:pPr>
             <a:r>
@@ -6180,6 +6102,7 @@
         <a:solidFill>
           <a:srgbClr val="F7F9F4"/>
         </a:solidFill>
+        <a:effectLst/>
       </p:bgPr>
     </p:bg>
     <p:spTree>
@@ -6217,7 +6140,7 @@
           <a:bodyPr wrap="square" lIns="0" tIns="0" rIns="0" bIns="0" rtlCol="0" anchor="ctr"/>
           <a:lstStyle/>
           <a:p>
-            <a:pPr indent="0" marL="0">
+            <a:pPr marL="0" indent="0">
               <a:buNone/>
             </a:pPr>
             <a:r>
@@ -6237,7 +6160,7 @@
       </p:sp>
       <p:graphicFrame>
         <p:nvGraphicFramePr>
-          <p:cNvPr id="3" name="Chart 0" descr=""/>
+          <p:cNvPr id="3" name="Chart 0"/>
           <p:cNvGraphicFramePr/>
           <p:nvPr/>
         </p:nvGraphicFramePr>
@@ -6245,9 +6168,9 @@
           <a:off x="365760" y="1051560"/>
           <a:ext cx="5760720" cy="3429000"/>
         </p:xfrm>
-        <a:graphic xmlns:a="http://schemas.openxmlformats.org/drawingml/2006/main">
+        <a:graphic>
           <a:graphicData uri="http://schemas.openxmlformats.org/drawingml/2006/chart">
-            <c:chart xmlns:c="http://schemas.openxmlformats.org/drawingml/2006/chart" r:id="rId1"/>
+            <c:chart xmlns:c="http://schemas.openxmlformats.org/drawingml/2006/chart" xmlns:r="http://schemas.openxmlformats.org/officeDocument/2006/relationships" r:id="rId3"/>
           </a:graphicData>
         </a:graphic>
       </p:graphicFrame>
@@ -6270,13 +6193,20 @@
           </a:solidFill>
           <a:ln/>
           <a:effectLst>
-            <a:outerShdw sx="100000" sy="100000" kx="0" ky="0" algn="bl" rotWithShape="0" blurRad="76200" dist="25400" dir="8100000">
+            <a:outerShdw blurRad="76200" dist="25400" dir="8100000" algn="bl" rotWithShape="0">
               <a:srgbClr val="000000">
                 <a:alpha val="15000"/>
               </a:srgbClr>
             </a:outerShdw>
           </a:effectLst>
         </p:spPr>
+        <p:txBody>
+          <a:bodyPr/>
+          <a:lstStyle/>
+          <a:p>
+            <a:endParaRPr lang="it-IT"/>
+          </a:p>
+        </p:txBody>
       </p:sp>
       <p:sp>
         <p:nvSpPr>
@@ -6299,7 +6229,7 @@
           <a:bodyPr wrap="square" lIns="0" tIns="0" rIns="0" bIns="0" rtlCol="0" anchor="ctr"/>
           <a:lstStyle/>
           <a:p>
-            <a:pPr algn="ctr" indent="0" marL="0">
+            <a:pPr marL="0" indent="0" algn="ctr">
               <a:buNone/>
             </a:pPr>
             <a:r>
@@ -6338,7 +6268,7 @@
           <a:bodyPr wrap="square" lIns="0" tIns="0" rIns="0" bIns="0" rtlCol="0" anchor="ctr"/>
           <a:lstStyle/>
           <a:p>
-            <a:pPr algn="ctr" indent="0" marL="0">
+            <a:pPr marL="0" indent="0" algn="ctr">
               <a:buNone/>
             </a:pPr>
             <a:r>
@@ -6377,7 +6307,7 @@
           <a:bodyPr wrap="square" lIns="0" tIns="0" rIns="0" bIns="0" rtlCol="0" anchor="ctr"/>
           <a:lstStyle/>
           <a:p>
-            <a:pPr indent="0" marL="0">
+            <a:pPr marL="0" indent="0">
               <a:buNone/>
             </a:pPr>
             <a:r>
@@ -6391,9 +6321,6 @@
               </a:rPr>
               <a:t>Ablation: </a:t>
             </a:r>
-            <a:pPr indent="0" marL="0">
-              <a:buNone/>
-            </a:pPr>
             <a:r>
               <a:rPr lang="en-US" sz="1100" dirty="0">
                 <a:solidFill>
@@ -6408,7 +6335,7 @@
             <a:endParaRPr lang="en-US" sz="1100" dirty="0"/>
           </a:p>
           <a:p>
-            <a:pPr indent="0" marL="0">
+            <a:pPr marL="0" indent="0">
               <a:buNone/>
             </a:pPr>
             <a:r>
@@ -6425,7 +6352,7 @@
             <a:endParaRPr lang="en-US" sz="1100" dirty="0"/>
           </a:p>
           <a:p>
-            <a:pPr indent="0" marL="0">
+            <a:pPr marL="0" indent="0">
               <a:buNone/>
             </a:pPr>
             <a:r>
@@ -6464,7 +6391,7 @@
           <a:bodyPr wrap="square" lIns="0" tIns="0" rIns="0" bIns="0" rtlCol="0" anchor="ctr"/>
           <a:lstStyle/>
           <a:p>
-            <a:pPr indent="0" marL="0">
+            <a:pPr marL="0" indent="0">
               <a:buNone/>
             </a:pPr>
             <a:r>
@@ -6503,7 +6430,7 @@
           <a:bodyPr wrap="square" rtlCol="0" anchor="ctr"/>
           <a:lstStyle/>
           <a:p>
-            <a:pPr indent="0" marL="0">
+            <a:pPr marL="0" indent="0">
               <a:buNone/>
             </a:pPr>
             <a:r>
@@ -6537,6 +6464,7 @@
         <a:solidFill>
           <a:srgbClr val="F7F9F4"/>
         </a:solidFill>
+        <a:effectLst/>
       </p:bgPr>
     </p:bg>
     <p:spTree>
@@ -6574,7 +6502,7 @@
           <a:bodyPr wrap="square" lIns="0" tIns="0" rIns="0" bIns="0" rtlCol="0" anchor="ctr"/>
           <a:lstStyle/>
           <a:p>
-            <a:pPr indent="0" marL="0">
+            <a:pPr marL="0" indent="0">
               <a:buNone/>
             </a:pPr>
             <a:r>
@@ -6613,7 +6541,7 @@
           <a:bodyPr wrap="square" lIns="0" tIns="0" rIns="0" bIns="0" rtlCol="0" anchor="ctr"/>
           <a:lstStyle/>
           <a:p>
-            <a:pPr indent="0" marL="0">
+            <a:pPr marL="0" indent="0">
               <a:buNone/>
             </a:pPr>
             <a:r>
@@ -6655,13 +6583,20 @@
             <a:prstDash val="solid"/>
           </a:ln>
           <a:effectLst>
-            <a:outerShdw sx="100000" sy="100000" kx="0" ky="0" algn="bl" rotWithShape="0" blurRad="63500" dist="25400" dir="8100000">
+            <a:outerShdw blurRad="63500" dist="25400" dir="8100000" algn="bl" rotWithShape="0">
               <a:srgbClr val="000000">
                 <a:alpha val="10000"/>
               </a:srgbClr>
             </a:outerShdw>
           </a:effectLst>
         </p:spPr>
+        <p:txBody>
+          <a:bodyPr/>
+          <a:lstStyle/>
+          <a:p>
+            <a:endParaRPr lang="it-IT"/>
+          </a:p>
+        </p:txBody>
       </p:sp>
       <p:sp>
         <p:nvSpPr>
@@ -6684,7 +6619,7 @@
           <a:bodyPr wrap="square" lIns="0" tIns="0" rIns="0" bIns="0" rtlCol="0" anchor="ctr"/>
           <a:lstStyle/>
           <a:p>
-            <a:pPr indent="0" marL="0">
+            <a:pPr marL="0" indent="0">
               <a:buNone/>
             </a:pPr>
             <a:r>
@@ -6723,7 +6658,7 @@
           <a:bodyPr wrap="square" lIns="0" tIns="0" rIns="0" bIns="0" rtlCol="0" anchor="ctr"/>
           <a:lstStyle/>
           <a:p>
-            <a:pPr indent="0" marL="0">
+            <a:pPr marL="0" indent="0">
               <a:buNone/>
             </a:pPr>
             <a:r>
@@ -6764,6 +6699,13 @@
             <a:tailEnd type="triangle"/>
           </a:ln>
         </p:spPr>
+        <p:txBody>
+          <a:bodyPr/>
+          <a:lstStyle/>
+          <a:p>
+            <a:endParaRPr lang="it-IT"/>
+          </a:p>
+        </p:txBody>
       </p:sp>
       <p:sp>
         <p:nvSpPr>
@@ -6789,13 +6731,20 @@
             <a:prstDash val="solid"/>
           </a:ln>
           <a:effectLst>
-            <a:outerShdw sx="100000" sy="100000" kx="0" ky="0" algn="bl" rotWithShape="0" blurRad="63500" dist="25400" dir="8100000">
+            <a:outerShdw blurRad="63500" dist="25400" dir="8100000" algn="bl" rotWithShape="0">
               <a:srgbClr val="000000">
                 <a:alpha val="10000"/>
               </a:srgbClr>
             </a:outerShdw>
           </a:effectLst>
         </p:spPr>
+        <p:txBody>
+          <a:bodyPr/>
+          <a:lstStyle/>
+          <a:p>
+            <a:endParaRPr lang="it-IT"/>
+          </a:p>
+        </p:txBody>
       </p:sp>
       <p:sp>
         <p:nvSpPr>
@@ -6818,7 +6767,7 @@
           <a:bodyPr wrap="square" lIns="0" tIns="0" rIns="0" bIns="0" rtlCol="0" anchor="ctr"/>
           <a:lstStyle/>
           <a:p>
-            <a:pPr indent="0" marL="0">
+            <a:pPr marL="0" indent="0">
               <a:buNone/>
             </a:pPr>
             <a:r>
@@ -6857,7 +6806,7 @@
           <a:bodyPr wrap="square" lIns="0" tIns="0" rIns="0" bIns="0" rtlCol="0" anchor="ctr"/>
           <a:lstStyle/>
           <a:p>
-            <a:pPr indent="0" marL="0">
+            <a:pPr marL="0" indent="0">
               <a:buNone/>
             </a:pPr>
             <a:r>
@@ -6898,6 +6847,13 @@
             <a:tailEnd type="triangle"/>
           </a:ln>
         </p:spPr>
+        <p:txBody>
+          <a:bodyPr/>
+          <a:lstStyle/>
+          <a:p>
+            <a:endParaRPr lang="it-IT"/>
+          </a:p>
+        </p:txBody>
       </p:sp>
       <p:sp>
         <p:nvSpPr>
@@ -6923,13 +6879,20 @@
             <a:prstDash val="solid"/>
           </a:ln>
           <a:effectLst>
-            <a:outerShdw sx="100000" sy="100000" kx="0" ky="0" algn="bl" rotWithShape="0" blurRad="63500" dist="25400" dir="8100000">
+            <a:outerShdw blurRad="63500" dist="25400" dir="8100000" algn="bl" rotWithShape="0">
               <a:srgbClr val="000000">
                 <a:alpha val="10000"/>
               </a:srgbClr>
             </a:outerShdw>
           </a:effectLst>
         </p:spPr>
+        <p:txBody>
+          <a:bodyPr/>
+          <a:lstStyle/>
+          <a:p>
+            <a:endParaRPr lang="it-IT"/>
+          </a:p>
+        </p:txBody>
       </p:sp>
       <p:sp>
         <p:nvSpPr>
@@ -6952,7 +6915,7 @@
           <a:bodyPr wrap="square" lIns="0" tIns="0" rIns="0" bIns="0" rtlCol="0" anchor="ctr"/>
           <a:lstStyle/>
           <a:p>
-            <a:pPr indent="0" marL="0">
+            <a:pPr marL="0" indent="0">
               <a:buNone/>
             </a:pPr>
             <a:r>
@@ -6991,7 +6954,7 @@
           <a:bodyPr wrap="square" lIns="0" tIns="0" rIns="0" bIns="0" rtlCol="0" anchor="ctr"/>
           <a:lstStyle/>
           <a:p>
-            <a:pPr indent="0" marL="0">
+            <a:pPr marL="0" indent="0">
               <a:buNone/>
             </a:pPr>
             <a:r>
@@ -7032,6 +6995,13 @@
             <a:tailEnd type="triangle"/>
           </a:ln>
         </p:spPr>
+        <p:txBody>
+          <a:bodyPr/>
+          <a:lstStyle/>
+          <a:p>
+            <a:endParaRPr lang="it-IT"/>
+          </a:p>
+        </p:txBody>
       </p:sp>
       <p:sp>
         <p:nvSpPr>
@@ -7057,13 +7027,20 @@
             <a:prstDash val="solid"/>
           </a:ln>
           <a:effectLst>
-            <a:outerShdw sx="100000" sy="100000" kx="0" ky="0" algn="bl" rotWithShape="0" blurRad="63500" dist="25400" dir="8100000">
+            <a:outerShdw blurRad="63500" dist="25400" dir="8100000" algn="bl" rotWithShape="0">
               <a:srgbClr val="000000">
                 <a:alpha val="10000"/>
               </a:srgbClr>
             </a:outerShdw>
           </a:effectLst>
         </p:spPr>
+        <p:txBody>
+          <a:bodyPr/>
+          <a:lstStyle/>
+          <a:p>
+            <a:endParaRPr lang="it-IT"/>
+          </a:p>
+        </p:txBody>
       </p:sp>
       <p:sp>
         <p:nvSpPr>
@@ -7086,7 +7063,7 @@
           <a:bodyPr wrap="square" lIns="0" tIns="0" rIns="0" bIns="0" rtlCol="0" anchor="ctr"/>
           <a:lstStyle/>
           <a:p>
-            <a:pPr indent="0" marL="0">
+            <a:pPr marL="0" indent="0">
               <a:buNone/>
             </a:pPr>
             <a:r>
@@ -7125,7 +7102,7 @@
           <a:bodyPr wrap="square" lIns="0" tIns="0" rIns="0" bIns="0" rtlCol="0" anchor="ctr"/>
           <a:lstStyle/>
           <a:p>
-            <a:pPr indent="0" marL="0">
+            <a:pPr marL="0" indent="0">
               <a:buNone/>
             </a:pPr>
             <a:r>
@@ -7164,7 +7141,7 @@
           <a:bodyPr wrap="square" lIns="0" tIns="0" rIns="0" bIns="0" rtlCol="0" anchor="ctr"/>
           <a:lstStyle/>
           <a:p>
-            <a:pPr indent="0" marL="0">
+            <a:pPr marL="0" indent="0">
               <a:buNone/>
             </a:pPr>
             <a:r>
@@ -7203,7 +7180,7 @@
           <a:bodyPr wrap="square" lIns="0" tIns="0" rIns="0" bIns="0" rtlCol="0" anchor="ctr"/>
           <a:lstStyle/>
           <a:p>
-            <a:pPr indent="0" marL="0">
+            <a:pPr marL="0" indent="0">
               <a:buNone/>
             </a:pPr>
             <a:r>
@@ -7217,9 +7194,6 @@
               </a:rPr>
               <a:t>Front-matter collisions — </a:t>
             </a:r>
-            <a:pPr indent="0" marL="0">
-              <a:buNone/>
-            </a:pPr>
             <a:r>
               <a:rPr lang="en-US" sz="1150" dirty="0">
                 <a:solidFill>
@@ -7231,9 +7205,6 @@
               </a:rPr>
               <a:t>the “Summary of Law changes” section repeats key terms densely enough to outrank the actual Law text.  </a:t>
             </a:r>
-            <a:pPr indent="0" marL="0">
-              <a:buNone/>
-            </a:pPr>
             <a:r>
               <a:rPr lang="en-US" sz="1150" i="1" dirty="0">
                 <a:solidFill>
@@ -7248,7 +7219,7 @@
             <a:endParaRPr lang="en-US" sz="1150" dirty="0"/>
           </a:p>
           <a:p>
-            <a:pPr indent="0" marL="0">
+            <a:pPr marL="0" indent="0">
               <a:buNone/>
             </a:pPr>
             <a:r>
@@ -7265,7 +7236,7 @@
             <a:endParaRPr lang="en-US" sz="1150" dirty="0"/>
           </a:p>
           <a:p>
-            <a:pPr indent="0" marL="0">
+            <a:pPr marL="0" indent="0">
               <a:buNone/>
             </a:pPr>
             <a:r>
@@ -7279,9 +7250,6 @@
               </a:rPr>
               <a:t>Low-information queries — </a:t>
             </a:r>
-            <a:pPr indent="0" marL="0">
-              <a:buNone/>
-            </a:pPr>
             <a:r>
               <a:rPr lang="en-US" sz="1150" dirty="0">
                 <a:solidFill>
@@ -7293,9 +7261,6 @@
               </a:rPr>
               <a:t>“When is a goal scored?” has two content words, both ubiquitous in this corpus.  </a:t>
             </a:r>
-            <a:pPr indent="0" marL="0">
-              <a:buNone/>
-            </a:pPr>
             <a:r>
               <a:rPr lang="en-US" sz="1150" i="1" dirty="0">
                 <a:solidFill>
@@ -7332,7 +7297,7 @@
           <a:bodyPr wrap="square" rtlCol="0" anchor="ctr"/>
           <a:lstStyle/>
           <a:p>
-            <a:pPr indent="0" marL="0">
+            <a:pPr marL="0" indent="0">
               <a:buNone/>
             </a:pPr>
             <a:r>
@@ -7366,6 +7331,7 @@
         <a:solidFill>
           <a:srgbClr val="F7F9F4"/>
         </a:solidFill>
+        <a:effectLst/>
       </p:bgPr>
     </p:bg>
     <p:spTree>
@@ -7403,7 +7369,7 @@
           <a:bodyPr wrap="square" lIns="0" tIns="0" rIns="0" bIns="0" rtlCol="0" anchor="ctr"/>
           <a:lstStyle/>
           <a:p>
-            <a:pPr indent="0" marL="0">
+            <a:pPr marL="0" indent="0">
               <a:buNone/>
             </a:pPr>
             <a:r>
@@ -7445,6 +7411,13 @@
             <a:prstDash val="solid"/>
           </a:ln>
         </p:spPr>
+        <p:txBody>
+          <a:bodyPr/>
+          <a:lstStyle/>
+          <a:p>
+            <a:endParaRPr lang="it-IT"/>
+          </a:p>
+        </p:txBody>
       </p:sp>
       <p:sp>
         <p:nvSpPr>
@@ -7465,6 +7438,13 @@
           </a:solidFill>
           <a:ln/>
         </p:spPr>
+        <p:txBody>
+          <a:bodyPr/>
+          <a:lstStyle/>
+          <a:p>
+            <a:endParaRPr lang="it-IT"/>
+          </a:p>
+        </p:txBody>
       </p:sp>
       <p:sp>
         <p:nvSpPr>
@@ -7487,7 +7467,7 @@
           <a:bodyPr wrap="square" lIns="0" tIns="0" rIns="0" bIns="0" rtlCol="0" anchor="ctr"/>
           <a:lstStyle/>
           <a:p>
-            <a:pPr indent="0" marL="0">
+            <a:pPr marL="0" indent="0">
               <a:buNone/>
             </a:pPr>
             <a:r>
@@ -7526,7 +7506,7 @@
           <a:bodyPr wrap="square" lIns="0" tIns="0" rIns="0" bIns="0" rtlCol="0" anchor="ctr"/>
           <a:lstStyle/>
           <a:p>
-            <a:pPr indent="0" marL="0">
+            <a:pPr marL="0" indent="0">
               <a:buNone/>
             </a:pPr>
             <a:r>
@@ -7568,6 +7548,13 @@
             <a:prstDash val="solid"/>
           </a:ln>
         </p:spPr>
+        <p:txBody>
+          <a:bodyPr/>
+          <a:lstStyle/>
+          <a:p>
+            <a:endParaRPr lang="it-IT"/>
+          </a:p>
+        </p:txBody>
       </p:sp>
       <p:sp>
         <p:nvSpPr>
@@ -7588,6 +7575,13 @@
           </a:solidFill>
           <a:ln/>
         </p:spPr>
+        <p:txBody>
+          <a:bodyPr/>
+          <a:lstStyle/>
+          <a:p>
+            <a:endParaRPr lang="it-IT"/>
+          </a:p>
+        </p:txBody>
       </p:sp>
       <p:sp>
         <p:nvSpPr>
@@ -7610,7 +7604,7 @@
           <a:bodyPr wrap="square" lIns="0" tIns="0" rIns="0" bIns="0" rtlCol="0" anchor="ctr"/>
           <a:lstStyle/>
           <a:p>
-            <a:pPr indent="0" marL="0">
+            <a:pPr marL="0" indent="0">
               <a:buNone/>
             </a:pPr>
             <a:r>
@@ -7649,7 +7643,7 @@
           <a:bodyPr wrap="square" lIns="0" tIns="0" rIns="0" bIns="0" rtlCol="0" anchor="ctr"/>
           <a:lstStyle/>
           <a:p>
-            <a:pPr indent="0" marL="0">
+            <a:pPr marL="0" indent="0">
               <a:buNone/>
             </a:pPr>
             <a:r>
@@ -7691,6 +7685,13 @@
             <a:prstDash val="solid"/>
           </a:ln>
         </p:spPr>
+        <p:txBody>
+          <a:bodyPr/>
+          <a:lstStyle/>
+          <a:p>
+            <a:endParaRPr lang="it-IT"/>
+          </a:p>
+        </p:txBody>
       </p:sp>
       <p:sp>
         <p:nvSpPr>
@@ -7711,6 +7712,13 @@
           </a:solidFill>
           <a:ln/>
         </p:spPr>
+        <p:txBody>
+          <a:bodyPr/>
+          <a:lstStyle/>
+          <a:p>
+            <a:endParaRPr lang="it-IT"/>
+          </a:p>
+        </p:txBody>
       </p:sp>
       <p:sp>
         <p:nvSpPr>
@@ -7733,7 +7741,7 @@
           <a:bodyPr wrap="square" lIns="0" tIns="0" rIns="0" bIns="0" rtlCol="0" anchor="ctr"/>
           <a:lstStyle/>
           <a:p>
-            <a:pPr indent="0" marL="0">
+            <a:pPr marL="0" indent="0">
               <a:buNone/>
             </a:pPr>
             <a:r>
@@ -7772,7 +7780,7 @@
           <a:bodyPr wrap="square" lIns="0" tIns="0" rIns="0" bIns="0" rtlCol="0" anchor="ctr"/>
           <a:lstStyle/>
           <a:p>
-            <a:pPr indent="0" marL="0">
+            <a:pPr marL="0" indent="0">
               <a:buNone/>
             </a:pPr>
             <a:r>
@@ -7814,6 +7822,13 @@
             <a:prstDash val="solid"/>
           </a:ln>
         </p:spPr>
+        <p:txBody>
+          <a:bodyPr/>
+          <a:lstStyle/>
+          <a:p>
+            <a:endParaRPr lang="it-IT"/>
+          </a:p>
+        </p:txBody>
       </p:sp>
       <p:sp>
         <p:nvSpPr>
@@ -7834,6 +7849,13 @@
           </a:solidFill>
           <a:ln/>
         </p:spPr>
+        <p:txBody>
+          <a:bodyPr/>
+          <a:lstStyle/>
+          <a:p>
+            <a:endParaRPr lang="it-IT"/>
+          </a:p>
+        </p:txBody>
       </p:sp>
       <p:sp>
         <p:nvSpPr>
@@ -7856,7 +7878,7 @@
           <a:bodyPr wrap="square" lIns="0" tIns="0" rIns="0" bIns="0" rtlCol="0" anchor="ctr"/>
           <a:lstStyle/>
           <a:p>
-            <a:pPr indent="0" marL="0">
+            <a:pPr marL="0" indent="0">
               <a:buNone/>
             </a:pPr>
             <a:r>
@@ -7895,7 +7917,7 @@
           <a:bodyPr wrap="square" lIns="0" tIns="0" rIns="0" bIns="0" rtlCol="0" anchor="ctr"/>
           <a:lstStyle/>
           <a:p>
-            <a:pPr indent="0" marL="0">
+            <a:pPr marL="0" indent="0">
               <a:buNone/>
             </a:pPr>
             <a:r>
@@ -7934,7 +7956,7 @@
           <a:bodyPr wrap="square" rtlCol="0" anchor="ctr"/>
           <a:lstStyle/>
           <a:p>
-            <a:pPr indent="0" marL="0">
+            <a:pPr marL="0" indent="0">
               <a:buNone/>
             </a:pPr>
             <a:r>
@@ -8253,4 +8275,319 @@
     </a:ext>
   </a:extLst>
 </a:theme>
+</file>
+
+<file path=ppt/theme/theme2.xml><?xml version="1.0" encoding="utf-8"?>
+<a:theme xmlns:a="http://schemas.openxmlformats.org/drawingml/2006/main" name="Tema di Office">
+  <a:themeElements>
+    <a:clrScheme name="Office">
+      <a:dk1>
+        <a:sysClr val="windowText" lastClr="000000"/>
+      </a:dk1>
+      <a:lt1>
+        <a:sysClr val="window" lastClr="FFFFFF"/>
+      </a:lt1>
+      <a:dk2>
+        <a:srgbClr val="0E2841"/>
+      </a:dk2>
+      <a:lt2>
+        <a:srgbClr val="E8E8E8"/>
+      </a:lt2>
+      <a:accent1>
+        <a:srgbClr val="156082"/>
+      </a:accent1>
+      <a:accent2>
+        <a:srgbClr val="E97132"/>
+      </a:accent2>
+      <a:accent3>
+        <a:srgbClr val="196B24"/>
+      </a:accent3>
+      <a:accent4>
+        <a:srgbClr val="0F9ED5"/>
+      </a:accent4>
+      <a:accent5>
+        <a:srgbClr val="A02B93"/>
+      </a:accent5>
+      <a:accent6>
+        <a:srgbClr val="4EA72E"/>
+      </a:accent6>
+      <a:hlink>
+        <a:srgbClr val="467886"/>
+      </a:hlink>
+      <a:folHlink>
+        <a:srgbClr val="96607D"/>
+      </a:folHlink>
+    </a:clrScheme>
+    <a:fontScheme name="Office">
+      <a:majorFont>
+        <a:latin typeface="Aptos Display" panose="02110004020202020204"/>
+        <a:ea typeface=""/>
+        <a:cs typeface=""/>
+        <a:font script="Jpan" typeface="游ゴシック Light"/>
+        <a:font script="Hang" typeface="맑은 고딕"/>
+        <a:font script="Hans" typeface="等线 Light"/>
+        <a:font script="Hant" typeface="新細明體"/>
+        <a:font script="Arab" typeface="Times New Roman"/>
+        <a:font script="Hebr" typeface="Times New Roman"/>
+        <a:font script="Thai" typeface="Angsana New"/>
+        <a:font script="Ethi" typeface="Nyala"/>
+        <a:font script="Beng" typeface="Vrinda"/>
+        <a:font script="Gujr" typeface="Shruti"/>
+        <a:font script="Khmr" typeface="MoolBoran"/>
+        <a:font script="Knda" typeface="Tunga"/>
+        <a:font script="Guru" typeface="Raavi"/>
+        <a:font script="Cans" typeface="Euphemia"/>
+        <a:font script="Cher" typeface="Plantagenet Cherokee"/>
+        <a:font script="Yiii" typeface="Microsoft Yi Baiti"/>
+        <a:font script="Tibt" typeface="Microsoft Himalaya"/>
+        <a:font script="Thaa" typeface="MV Boli"/>
+        <a:font script="Deva" typeface="Mangal"/>
+        <a:font script="Telu" typeface="Gautami"/>
+        <a:font script="Taml" typeface="Latha"/>
+        <a:font script="Syrc" typeface="Estrangelo Edessa"/>
+        <a:font script="Orya" typeface="Kalinga"/>
+        <a:font script="Mlym" typeface="Kartika"/>
+        <a:font script="Laoo" typeface="DokChampa"/>
+        <a:font script="Sinh" typeface="Iskoola Pota"/>
+        <a:font script="Mong" typeface="Mongolian Baiti"/>
+        <a:font script="Viet" typeface="Times New Roman"/>
+        <a:font script="Uigh" typeface="Microsoft Uighur"/>
+        <a:font script="Geor" typeface="Sylfaen"/>
+        <a:font script="Armn" typeface="Arial"/>
+        <a:font script="Bugi" typeface="Leelawadee UI"/>
+        <a:font script="Bopo" typeface="Microsoft JhengHei"/>
+        <a:font script="Java" typeface="Javanese Text"/>
+        <a:font script="Lisu" typeface="Segoe UI"/>
+        <a:font script="Mymr" typeface="Myanmar Text"/>
+        <a:font script="Nkoo" typeface="Ebrima"/>
+        <a:font script="Olck" typeface="Nirmala UI"/>
+        <a:font script="Osma" typeface="Ebrima"/>
+        <a:font script="Phag" typeface="Phagspa"/>
+        <a:font script="Syrn" typeface="Estrangelo Edessa"/>
+        <a:font script="Syrj" typeface="Estrangelo Edessa"/>
+        <a:font script="Syre" typeface="Estrangelo Edessa"/>
+        <a:font script="Sora" typeface="Nirmala UI"/>
+        <a:font script="Tale" typeface="Microsoft Tai Le"/>
+        <a:font script="Talu" typeface="Microsoft New Tai Lue"/>
+        <a:font script="Tfng" typeface="Ebrima"/>
+      </a:majorFont>
+      <a:minorFont>
+        <a:latin typeface="Aptos" panose="02110004020202020204"/>
+        <a:ea typeface=""/>
+        <a:cs typeface=""/>
+        <a:font script="Jpan" typeface="游ゴシック"/>
+        <a:font script="Hang" typeface="맑은 고딕"/>
+        <a:font script="Hans" typeface="等线"/>
+        <a:font script="Hant" typeface="新細明體"/>
+        <a:font script="Arab" typeface="Arial"/>
+        <a:font script="Hebr" typeface="Arial"/>
+        <a:font script="Thai" typeface="Cordia New"/>
+        <a:font script="Ethi" typeface="Nyala"/>
+        <a:font script="Beng" typeface="Vrinda"/>
+        <a:font script="Gujr" typeface="Shruti"/>
+        <a:font script="Khmr" typeface="DaunPenh"/>
+        <a:font script="Knda" typeface="Tunga"/>
+        <a:font script="Guru" typeface="Raavi"/>
+        <a:font script="Cans" typeface="Euphemia"/>
+        <a:font script="Cher" typeface="Plantagenet Cherokee"/>
+        <a:font script="Yiii" typeface="Microsoft Yi Baiti"/>
+        <a:font script="Tibt" typeface="Microsoft Himalaya"/>
+        <a:font script="Thaa" typeface="MV Boli"/>
+        <a:font script="Deva" typeface="Mangal"/>
+        <a:font script="Telu" typeface="Gautami"/>
+        <a:font script="Taml" typeface="Latha"/>
+        <a:font script="Syrc" typeface="Estrangelo Edessa"/>
+        <a:font script="Orya" typeface="Kalinga"/>
+        <a:font script="Mlym" typeface="Kartika"/>
+        <a:font script="Laoo" typeface="DokChampa"/>
+        <a:font script="Sinh" typeface="Iskoola Pota"/>
+        <a:font script="Mong" typeface="Mongolian Baiti"/>
+        <a:font script="Viet" typeface="Arial"/>
+        <a:font script="Uigh" typeface="Microsoft Uighur"/>
+        <a:font script="Geor" typeface="Sylfaen"/>
+        <a:font script="Armn" typeface="Arial"/>
+        <a:font script="Bugi" typeface="Leelawadee UI"/>
+        <a:font script="Bopo" typeface="Microsoft JhengHei"/>
+        <a:font script="Java" typeface="Javanese Text"/>
+        <a:font script="Lisu" typeface="Segoe UI"/>
+        <a:font script="Mymr" typeface="Myanmar Text"/>
+        <a:font script="Nkoo" typeface="Ebrima"/>
+        <a:font script="Olck" typeface="Nirmala UI"/>
+        <a:font script="Osma" typeface="Ebrima"/>
+        <a:font script="Phag" typeface="Phagspa"/>
+        <a:font script="Syrn" typeface="Estrangelo Edessa"/>
+        <a:font script="Syrj" typeface="Estrangelo Edessa"/>
+        <a:font script="Syre" typeface="Estrangelo Edessa"/>
+        <a:font script="Sora" typeface="Nirmala UI"/>
+        <a:font script="Tale" typeface="Microsoft Tai Le"/>
+        <a:font script="Talu" typeface="Microsoft New Tai Lue"/>
+        <a:font script="Tfng" typeface="Ebrima"/>
+      </a:minorFont>
+    </a:fontScheme>
+    <a:fmtScheme name="Office">
+      <a:fillStyleLst>
+        <a:solidFill>
+          <a:schemeClr val="phClr"/>
+        </a:solidFill>
+        <a:gradFill rotWithShape="1">
+          <a:gsLst>
+            <a:gs pos="0">
+              <a:schemeClr val="phClr">
+                <a:lumMod val="110000"/>
+                <a:satMod val="105000"/>
+                <a:tint val="67000"/>
+              </a:schemeClr>
+            </a:gs>
+            <a:gs pos="50000">
+              <a:schemeClr val="phClr">
+                <a:lumMod val="105000"/>
+                <a:satMod val="103000"/>
+                <a:tint val="73000"/>
+              </a:schemeClr>
+            </a:gs>
+            <a:gs pos="100000">
+              <a:schemeClr val="phClr">
+                <a:lumMod val="105000"/>
+                <a:satMod val="109000"/>
+                <a:tint val="81000"/>
+              </a:schemeClr>
+            </a:gs>
+          </a:gsLst>
+          <a:lin ang="5400000" scaled="0"/>
+        </a:gradFill>
+        <a:gradFill rotWithShape="1">
+          <a:gsLst>
+            <a:gs pos="0">
+              <a:schemeClr val="phClr">
+                <a:satMod val="103000"/>
+                <a:lumMod val="102000"/>
+                <a:tint val="94000"/>
+              </a:schemeClr>
+            </a:gs>
+            <a:gs pos="50000">
+              <a:schemeClr val="phClr">
+                <a:satMod val="110000"/>
+                <a:lumMod val="100000"/>
+                <a:shade val="100000"/>
+              </a:schemeClr>
+            </a:gs>
+            <a:gs pos="100000">
+              <a:schemeClr val="phClr">
+                <a:lumMod val="99000"/>
+                <a:satMod val="120000"/>
+                <a:shade val="78000"/>
+              </a:schemeClr>
+            </a:gs>
+          </a:gsLst>
+          <a:lin ang="5400000" scaled="0"/>
+        </a:gradFill>
+      </a:fillStyleLst>
+      <a:lnStyleLst>
+        <a:ln w="12700" cap="flat" cmpd="sng" algn="ctr">
+          <a:solidFill>
+            <a:schemeClr val="phClr"/>
+          </a:solidFill>
+          <a:prstDash val="solid"/>
+          <a:miter lim="800000"/>
+        </a:ln>
+        <a:ln w="19050" cap="flat" cmpd="sng" algn="ctr">
+          <a:solidFill>
+            <a:schemeClr val="phClr"/>
+          </a:solidFill>
+          <a:prstDash val="solid"/>
+          <a:miter lim="800000"/>
+        </a:ln>
+        <a:ln w="25400" cap="flat" cmpd="sng" algn="ctr">
+          <a:solidFill>
+            <a:schemeClr val="phClr"/>
+          </a:solidFill>
+          <a:prstDash val="solid"/>
+          <a:miter lim="800000"/>
+        </a:ln>
+      </a:lnStyleLst>
+      <a:effectStyleLst>
+        <a:effectStyle>
+          <a:effectLst/>
+        </a:effectStyle>
+        <a:effectStyle>
+          <a:effectLst/>
+        </a:effectStyle>
+        <a:effectStyle>
+          <a:effectLst>
+            <a:outerShdw blurRad="57150" dist="19050" dir="5400000" algn="ctr" rotWithShape="0">
+              <a:srgbClr val="000000">
+                <a:alpha val="63000"/>
+              </a:srgbClr>
+            </a:outerShdw>
+          </a:effectLst>
+        </a:effectStyle>
+      </a:effectStyleLst>
+      <a:bgFillStyleLst>
+        <a:solidFill>
+          <a:schemeClr val="phClr"/>
+        </a:solidFill>
+        <a:solidFill>
+          <a:schemeClr val="phClr">
+            <a:tint val="95000"/>
+            <a:satMod val="170000"/>
+          </a:schemeClr>
+        </a:solidFill>
+        <a:gradFill rotWithShape="1">
+          <a:gsLst>
+            <a:gs pos="0">
+              <a:schemeClr val="phClr">
+                <a:tint val="93000"/>
+                <a:satMod val="150000"/>
+                <a:shade val="98000"/>
+                <a:lumMod val="102000"/>
+              </a:schemeClr>
+            </a:gs>
+            <a:gs pos="50000">
+              <a:schemeClr val="phClr">
+                <a:tint val="98000"/>
+                <a:satMod val="130000"/>
+                <a:shade val="90000"/>
+                <a:lumMod val="103000"/>
+              </a:schemeClr>
+            </a:gs>
+            <a:gs pos="100000">
+              <a:schemeClr val="phClr">
+                <a:shade val="63000"/>
+                <a:satMod val="120000"/>
+              </a:schemeClr>
+            </a:gs>
+          </a:gsLst>
+          <a:lin ang="5400000" scaled="0"/>
+        </a:gradFill>
+      </a:bgFillStyleLst>
+    </a:fmtScheme>
+  </a:themeElements>
+  <a:objectDefaults>
+    <a:lnDef>
+      <a:spPr/>
+      <a:bodyPr/>
+      <a:lstStyle/>
+      <a:style>
+        <a:lnRef idx="2">
+          <a:schemeClr val="accent1"/>
+        </a:lnRef>
+        <a:fillRef idx="0">
+          <a:schemeClr val="accent1"/>
+        </a:fillRef>
+        <a:effectRef idx="1">
+          <a:schemeClr val="accent1"/>
+        </a:effectRef>
+        <a:fontRef idx="minor">
+          <a:schemeClr val="tx1"/>
+        </a:fontRef>
+      </a:style>
+    </a:lnDef>
+  </a:objectDefaults>
+  <a:extraClrSchemeLst/>
+  <a:extLst>
+    <a:ext uri="{05A4C25C-085E-4340-85A3-A5531E510DB2}">
+      <thm15:themeFamily xmlns:thm15="http://schemas.microsoft.com/office/thememl/2012/main" name="Office Theme" id="{2E142A2C-CD16-42D6-873A-C26D2A0506FA}" vid="{1BDDFF52-6CD6-40A5-AB3C-68EB2F1E4D0A}"/>
+    </a:ext>
+  </a:extLst>
+</a:theme>
 </file>
</xml_diff>

<commit_message>
Production & academic hardening pass
- rag/ reusable retrieval core (shared by API, eval, notebook, tests)
- fix token-boundary query expansion (keeper/var bug) + history-aware retrieval
- page-diverse retrieval; cleaned sentence-aware ingestion; regenerate chunks
- rename Recall@k -> Page Hit Rate@k; richer results.json; dev-set metadata
- answer-level eval harness + deterministic citation checks; corpus provenance
- API hardening (typed models, status, citation-validated sources, timeouts)
- patch Starlette CVE-2026-48710 (fastapi 0.136.3); split deploy/dev reqs
- 77 tests + CI (pytest, eval regression, notebook, pip-audit)
- rewrite README, notebook, slide deck (correct metrics/claims)
</commit_message>
<xml_diff>
--- a/laws_rag_presentation.pptx
+++ b/laws_rag_presentation.pptx
@@ -17,6 +17,8 @@
     <p:sldId id="262" r:id="rId8"/>
     <p:sldId id="263" r:id="rId9"/>
     <p:sldId id="264" r:id="rId10"/>
+    <p:sldId id="266" r:id="rId17"/>
+    <p:sldId id="267" r:id="rId18"/>
     <p:sldId id="265" r:id="rId11"/>
   </p:sldIdLst>
   <p:sldSz cx="9144000" cy="5143500" type="screen16x9"/>
@@ -144,7 +146,7 @@
               <c:strCache>
                 <c:ptCount val="1"/>
                 <c:pt idx="0">
-                  <c:v>BM25 + expansion (prod)</c:v>
+                  <c:v>BM25 + expansion + dedup (prod)</c:v>
                 </c:pt>
               </c:strCache>
             </c:strRef>
@@ -162,13 +164,13 @@
               <c:strCache>
                 <c:ptCount val="4"/>
                 <c:pt idx="0">
-                  <c:v>Recall@1</c:v>
+                  <c:v>hit@1</c:v>
                 </c:pt>
                 <c:pt idx="1">
-                  <c:v>Recall@3</c:v>
+                  <c:v>hit@3</c:v>
                 </c:pt>
                 <c:pt idx="2">
-                  <c:v>Recall@5</c:v>
+                  <c:v>hit@5</c:v>
                 </c:pt>
                 <c:pt idx="3">
                   <c:v>MRR@5</c:v>
@@ -183,16 +185,16 @@
                 <c:formatCode>General</c:formatCode>
                 <c:ptCount val="4"/>
                 <c:pt idx="0">
-                  <c:v>0.4</c:v>
+                  <c:v>0.45</c:v>
                 </c:pt>
                 <c:pt idx="1">
-                  <c:v>0.7</c:v>
+                  <c:v>0.6</c:v>
                 </c:pt>
                 <c:pt idx="2">
-                  <c:v>0.8</c:v>
+                  <c:v>0.75</c:v>
                 </c:pt>
                 <c:pt idx="3">
-                  <c:v>0.56000000000000005</c:v>
+                  <c:v>0.55</c:v>
                 </c:pt>
               </c:numCache>
             </c:numRef>
@@ -212,7 +214,7 @@
               <c:strCache>
                 <c:ptCount val="1"/>
                 <c:pt idx="0">
-                  <c:v>BM25 plain (ablation)</c:v>
+                  <c:v>BM25 plain (no expansion)</c:v>
                 </c:pt>
               </c:strCache>
             </c:strRef>
@@ -230,13 +232,13 @@
               <c:strCache>
                 <c:ptCount val="4"/>
                 <c:pt idx="0">
-                  <c:v>Recall@1</c:v>
+                  <c:v>hit@1</c:v>
                 </c:pt>
                 <c:pt idx="1">
-                  <c:v>Recall@3</c:v>
+                  <c:v>hit@3</c:v>
                 </c:pt>
                 <c:pt idx="2">
-                  <c:v>Recall@5</c:v>
+                  <c:v>hit@5</c:v>
                 </c:pt>
                 <c:pt idx="3">
                   <c:v>MRR@5</c:v>
@@ -251,16 +253,16 @@
                 <c:formatCode>General</c:formatCode>
                 <c:ptCount val="4"/>
                 <c:pt idx="0">
-                  <c:v>0.4</c:v>
+                  <c:v>0.45</c:v>
                 </c:pt>
                 <c:pt idx="1">
+                  <c:v>0.6</c:v>
+                </c:pt>
+                <c:pt idx="2">
                   <c:v>0.65</c:v>
                 </c:pt>
-                <c:pt idx="2">
-                  <c:v>0.7</c:v>
-                </c:pt>
                 <c:pt idx="3">
-                  <c:v>0.52</c:v>
+                  <c:v>0.53</c:v>
                 </c:pt>
               </c:numCache>
             </c:numRef>
@@ -298,13 +300,13 @@
               <c:strCache>
                 <c:ptCount val="4"/>
                 <c:pt idx="0">
-                  <c:v>Recall@1</c:v>
+                  <c:v>hit@1</c:v>
                 </c:pt>
                 <c:pt idx="1">
-                  <c:v>Recall@3</c:v>
+                  <c:v>hit@3</c:v>
                 </c:pt>
                 <c:pt idx="2">
-                  <c:v>Recall@5</c:v>
+                  <c:v>hit@5</c:v>
                 </c:pt>
                 <c:pt idx="3">
                   <c:v>MRR@5</c:v>
@@ -319,16 +321,16 @@
                 <c:formatCode>General</c:formatCode>
                 <c:ptCount val="4"/>
                 <c:pt idx="0">
-                  <c:v>0.45</c:v>
+                  <c:v>0.3</c:v>
                 </c:pt>
                 <c:pt idx="1">
-                  <c:v>0.65</c:v>
+                  <c:v>0.5</c:v>
                 </c:pt>
                 <c:pt idx="2">
-                  <c:v>0.65</c:v>
+                  <c:v>0.55</c:v>
                 </c:pt>
                 <c:pt idx="3">
-                  <c:v>0.53</c:v>
+                  <c:v>0.4</c:v>
                 </c:pt>
               </c:numCache>
             </c:numRef>
@@ -366,13 +368,13 @@
               <c:strCache>
                 <c:ptCount val="4"/>
                 <c:pt idx="0">
-                  <c:v>Recall@1</c:v>
+                  <c:v>hit@1</c:v>
                 </c:pt>
                 <c:pt idx="1">
-                  <c:v>Recall@3</c:v>
+                  <c:v>hit@3</c:v>
                 </c:pt>
                 <c:pt idx="2">
-                  <c:v>Recall@5</c:v>
+                  <c:v>hit@5</c:v>
                 </c:pt>
                 <c:pt idx="3">
                   <c:v>MRR@5</c:v>
@@ -387,7 +389,7 @@
                 <c:formatCode>General</c:formatCode>
                 <c:ptCount val="4"/>
                 <c:pt idx="0">
-                  <c:v>0</c:v>
+                  <c:v>0.05</c:v>
                 </c:pt>
                 <c:pt idx="1">
                   <c:v>0.05</c:v>
@@ -396,7 +398,7 @@
                   <c:v>0.05</c:v>
                 </c:pt>
                 <c:pt idx="3">
-                  <c:v>0.02</c:v>
+                  <c:v>0.05</c:v>
                 </c:pt>
               </c:numCache>
             </c:numRef>
@@ -2016,7 +2018,7 @@
                 <a:ea typeface="Calibri" pitchFamily="34" charset="-122"/>
                 <a:cs typeface="Calibri" pitchFamily="34" charset="-120"/>
               </a:rPr>
-              <a:t>An end-to-end RAG chatbot over the FIFA / IFAB Laws of the Game 2025/26</a:t>
+              <a:t>An end-to-end RAG chatbot over the FIFA / IFAB Laws of the Game 2025/26  ·  Educational — not affiliated with FIFA/IFAB</a:t>
             </a:r>
             <a:endParaRPr lang="en-US" sz="1700" dirty="0"/>
           </a:p>
@@ -2164,6 +2166,747 @@
 </file>
 
 <file path=ppt/slides/slide10.xml><?xml version="1.0" encoding="utf-8"?>
+<p:sld xmlns:a="http://schemas.openxmlformats.org/drawingml/2006/main" xmlns:p="http://schemas.openxmlformats.org/presentationml/2006/main" xmlns:r="http://schemas.openxmlformats.org/officeDocument/2006/relationships">
+  <p:cSld>
+    <p:spTree>
+      <p:nvGrpSpPr>
+        <p:cNvPr id="1" name=""/>
+        <p:cNvGrpSpPr/>
+        <p:nvPr/>
+      </p:nvGrpSpPr>
+      <p:grpSpPr/>
+      <p:sp>
+        <p:nvSpPr>
+          <p:cNvPr id="2" name="Rectangle 1"/>
+          <p:cNvSpPr/>
+          <p:nvPr/>
+        </p:nvSpPr>
+        <p:spPr>
+          <a:xfrm>
+            <a:off x="0" y="0"/>
+            <a:ext cx="9144000" cy="822960"/>
+          </a:xfrm>
+          <a:prstGeom prst="rect">
+            <a:avLst/>
+          </a:prstGeom>
+          <a:solidFill>
+            <a:srgbClr val="2D6A4F"/>
+          </a:solidFill>
+          <a:ln>
+            <a:noFill/>
+          </a:ln>
+        </p:spPr>
+        <p:style>
+          <a:lnRef idx="1">
+            <a:schemeClr val="accent1"/>
+          </a:lnRef>
+          <a:fillRef idx="3">
+            <a:schemeClr val="accent1"/>
+          </a:fillRef>
+          <a:effectRef idx="2">
+            <a:schemeClr val="accent1"/>
+          </a:effectRef>
+          <a:fontRef idx="minor">
+            <a:schemeClr val="lt1"/>
+          </a:fontRef>
+        </p:style>
+        <p:txBody>
+          <a:bodyPr rtlCol="0" anchor="ctr" lIns="457200" wrap="square"/>
+          <a:lstStyle/>
+          <a:p>
+            <a:pPr algn="ctr"/>
+            <a:r>
+              <a:rPr sz="2600" b="1">
+                <a:solidFill>
+                  <a:srgbClr val="FFFFFF"/>
+                </a:solidFill>
+              </a:rPr>
+              <a:t>It works — real system outputs</a:t>
+            </a:r>
+          </a:p>
+        </p:txBody>
+      </p:sp>
+      <p:sp>
+        <p:nvSpPr>
+          <p:cNvPr id="3" name="Rectangle 2"/>
+          <p:cNvSpPr/>
+          <p:nvPr/>
+        </p:nvSpPr>
+        <p:spPr>
+          <a:xfrm>
+            <a:off x="365760" y="1051560"/>
+            <a:ext cx="4160520" cy="1143000"/>
+          </a:xfrm>
+          <a:prstGeom prst="rect">
+            <a:avLst/>
+          </a:prstGeom>
+          <a:solidFill>
+            <a:srgbClr val="F2F7F4"/>
+          </a:solidFill>
+          <a:ln w="12700">
+            <a:solidFill>
+              <a:srgbClr val="2D6A4F"/>
+            </a:solidFill>
+          </a:ln>
+        </p:spPr>
+        <p:style>
+          <a:lnRef idx="1">
+            <a:schemeClr val="accent1"/>
+          </a:lnRef>
+          <a:fillRef idx="3">
+            <a:schemeClr val="accent1"/>
+          </a:fillRef>
+          <a:effectRef idx="2">
+            <a:schemeClr val="accent1"/>
+          </a:effectRef>
+          <a:fontRef idx="minor">
+            <a:schemeClr val="lt1"/>
+          </a:fontRef>
+        </p:style>
+        <p:txBody>
+          <a:bodyPr rtlCol="0" anchor="ctr" wrap="square" lIns="164592" rIns="164592" tIns="128016"/>
+          <a:lstStyle/>
+          <a:p>
+            <a:pPr algn="ctr"/>
+            <a:r>
+              <a:rPr sz="1400" b="1">
+                <a:solidFill>
+                  <a:srgbClr val="1B4332"/>
+                </a:solidFill>
+              </a:rPr>
+              <a:t>In-domain question · grounded</a:t>
+            </a:r>
+          </a:p>
+          <a:p>
+            <a:r>
+              <a:rPr sz="1150">
+                <a:solidFill>
+                  <a:srgbClr val="5A6B62"/>
+                </a:solidFill>
+              </a:rPr>
+              <a:t>“How long is the half-time interval?” → retrieves p.87 (real). Page 87 states the interval must not exceed 15 minutes; a grounded answer cites [p. 87].</a:t>
+            </a:r>
+          </a:p>
+        </p:txBody>
+      </p:sp>
+      <p:sp>
+        <p:nvSpPr>
+          <p:cNvPr id="4" name="Rectangle 3"/>
+          <p:cNvSpPr/>
+          <p:nvPr/>
+        </p:nvSpPr>
+        <p:spPr>
+          <a:xfrm>
+            <a:off x="4617720" y="1051560"/>
+            <a:ext cx="4160520" cy="1143000"/>
+          </a:xfrm>
+          <a:prstGeom prst="rect">
+            <a:avLst/>
+          </a:prstGeom>
+          <a:solidFill>
+            <a:srgbClr val="F2F7F4"/>
+          </a:solidFill>
+          <a:ln w="12700">
+            <a:solidFill>
+              <a:srgbClr val="2D6A4F"/>
+            </a:solidFill>
+          </a:ln>
+        </p:spPr>
+        <p:style>
+          <a:lnRef idx="1">
+            <a:schemeClr val="accent1"/>
+          </a:lnRef>
+          <a:fillRef idx="3">
+            <a:schemeClr val="accent1"/>
+          </a:fillRef>
+          <a:effectRef idx="2">
+            <a:schemeClr val="accent1"/>
+          </a:effectRef>
+          <a:fontRef idx="minor">
+            <a:schemeClr val="lt1"/>
+          </a:fontRef>
+        </p:style>
+        <p:txBody>
+          <a:bodyPr rtlCol="0" anchor="ctr" wrap="square" lIns="164592" rIns="164592" tIns="128016"/>
+          <a:lstStyle/>
+          <a:p>
+            <a:pPr algn="ctr"/>
+            <a:r>
+              <a:rPr sz="1400" b="1">
+                <a:solidFill>
+                  <a:srgbClr val="1B4332"/>
+                </a:solidFill>
+              </a:rPr>
+              <a:t>Out-of-domain · refusal hides sources</a:t>
+            </a:r>
+          </a:p>
+          <a:p>
+            <a:r>
+              <a:rPr sz="1150">
+                <a:solidFill>
+                  <a:srgbClr val="5A6B62"/>
+                </a:solidFill>
+              </a:rPr>
+              <a:t>“Who won the 2022 World Cup?” → status out_of_scope, answer declines, and ZERO source badges are shown (refusals never display irrelevant pages).</a:t>
+            </a:r>
+          </a:p>
+        </p:txBody>
+      </p:sp>
+      <p:sp>
+        <p:nvSpPr>
+          <p:cNvPr id="5" name="Rectangle 4"/>
+          <p:cNvSpPr/>
+          <p:nvPr/>
+        </p:nvSpPr>
+        <p:spPr>
+          <a:xfrm>
+            <a:off x="365760" y="2423160"/>
+            <a:ext cx="4160520" cy="1143000"/>
+          </a:xfrm>
+          <a:prstGeom prst="rect">
+            <a:avLst/>
+          </a:prstGeom>
+          <a:solidFill>
+            <a:srgbClr val="F2F7F4"/>
+          </a:solidFill>
+          <a:ln w="12700">
+            <a:solidFill>
+              <a:srgbClr val="2D6A4F"/>
+            </a:solidFill>
+          </a:ln>
+        </p:spPr>
+        <p:style>
+          <a:lnRef idx="1">
+            <a:schemeClr val="accent1"/>
+          </a:lnRef>
+          <a:fillRef idx="3">
+            <a:schemeClr val="accent1"/>
+          </a:fillRef>
+          <a:effectRef idx="2">
+            <a:schemeClr val="accent1"/>
+          </a:effectRef>
+          <a:fontRef idx="minor">
+            <a:schemeClr val="lt1"/>
+          </a:fontRef>
+        </p:style>
+        <p:txBody>
+          <a:bodyPr rtlCol="0" anchor="ctr" wrap="square" lIns="164592" rIns="164592" tIns="128016"/>
+          <a:lstStyle/>
+          <a:p>
+            <a:pPr algn="ctr"/>
+            <a:r>
+              <a:rPr sz="1400" b="1">
+                <a:solidFill>
+                  <a:srgbClr val="1B4332"/>
+                </a:solidFill>
+              </a:rPr>
+              <a:t>Conversational follow-up fix</a:t>
+            </a:r>
+          </a:p>
+          <a:p>
+            <a:r>
+              <a:rPr sz="1150">
+                <a:solidFill>
+                  <a:srgbClr val="5A6B62"/>
+                </a:solidFill>
+              </a:rPr>
+              <a:t>After “What is the offside rule?”, the follow-up “What are the exceptions?” is rewritten for retrieval to “What are the exceptions? offside rule”, staying on topic.</a:t>
+            </a:r>
+          </a:p>
+        </p:txBody>
+      </p:sp>
+      <p:sp>
+        <p:nvSpPr>
+          <p:cNvPr id="6" name="Rectangle 5"/>
+          <p:cNvSpPr/>
+          <p:nvPr/>
+        </p:nvSpPr>
+        <p:spPr>
+          <a:xfrm>
+            <a:off x="4617720" y="2423160"/>
+            <a:ext cx="4160520" cy="1143000"/>
+          </a:xfrm>
+          <a:prstGeom prst="rect">
+            <a:avLst/>
+          </a:prstGeom>
+          <a:solidFill>
+            <a:srgbClr val="F2F7F4"/>
+          </a:solidFill>
+          <a:ln w="12700">
+            <a:solidFill>
+              <a:srgbClr val="2D6A4F"/>
+            </a:solidFill>
+          </a:ln>
+        </p:spPr>
+        <p:style>
+          <a:lnRef idx="1">
+            <a:schemeClr val="accent1"/>
+          </a:lnRef>
+          <a:fillRef idx="3">
+            <a:schemeClr val="accent1"/>
+          </a:fillRef>
+          <a:effectRef idx="2">
+            <a:schemeClr val="accent1"/>
+          </a:effectRef>
+          <a:fontRef idx="minor">
+            <a:schemeClr val="lt1"/>
+          </a:fontRef>
+        </p:style>
+        <p:txBody>
+          <a:bodyPr rtlCol="0" anchor="ctr" wrap="square" lIns="164592" rIns="164592" tIns="128016"/>
+          <a:lstStyle/>
+          <a:p>
+            <a:pPr algn="ctr"/>
+            <a:r>
+              <a:rPr sz="1400" b="1">
+                <a:solidFill>
+                  <a:srgbClr val="1B4332"/>
+                </a:solidFill>
+              </a:rPr>
+              <a:t>Citation validation</a:t>
+            </a:r>
+          </a:p>
+          <a:p>
+            <a:r>
+              <a:rPr sz="1150">
+                <a:solidFill>
+                  <a:srgbClr val="5A6B62"/>
+                </a:solidFill>
+              </a:rPr>
+              <a:t>Only pages the answer actually cites — and that were retrieved — become source badges; a cite to an un-retrieved page is dropped and the answer is flagged not-grounded.</a:t>
+            </a:r>
+          </a:p>
+        </p:txBody>
+      </p:sp>
+      <p:sp>
+        <p:nvSpPr>
+          <p:cNvPr id="7" name="TextBox 6"/>
+          <p:cNvSpPr txBox="1"/>
+          <p:nvPr/>
+        </p:nvSpPr>
+        <p:spPr>
+          <a:xfrm>
+            <a:off x="365760" y="3657600"/>
+            <a:ext cx="8412480" cy="365760"/>
+          </a:xfrm>
+          <a:prstGeom prst="rect">
+            <a:avLst/>
+          </a:prstGeom>
+          <a:noFill/>
+        </p:spPr>
+        <p:txBody>
+          <a:bodyPr wrap="none">
+            <a:spAutoFit/>
+          </a:bodyPr>
+          <a:lstStyle/>
+          <a:p>
+            <a:r>
+              <a:rPr sz="1000" i="1">
+                <a:solidFill>
+                  <a:srgbClr val="5A6B62"/>
+                </a:solidFill>
+              </a:rPr>
+              <a:t>Retrieval, refusal and rewrite shown are actual outputs (no key needed). The generated answer text itself requires a Groq key and is not fabricated here.</a:t>
+            </a:r>
+          </a:p>
+        </p:txBody>
+      </p:sp>
+      <p:sp>
+        <p:nvSpPr>
+          <p:cNvPr id="8" name="TextBox 7"/>
+          <p:cNvSpPr txBox="1"/>
+          <p:nvPr/>
+        </p:nvSpPr>
+        <p:spPr>
+          <a:xfrm>
+            <a:off x="365760" y="4777740"/>
+            <a:ext cx="5486400" cy="274320"/>
+          </a:xfrm>
+          <a:prstGeom prst="rect">
+            <a:avLst/>
+          </a:prstGeom>
+          <a:noFill/>
+        </p:spPr>
+        <p:txBody>
+          <a:bodyPr wrap="none">
+            <a:spAutoFit/>
+          </a:bodyPr>
+          <a:lstStyle/>
+          <a:p>
+            <a:r>
+              <a:rPr sz="900">
+                <a:solidFill>
+                  <a:srgbClr val="5A6B62"/>
+                </a:solidFill>
+              </a:rPr>
+              <a:t>Laws of the Game RAG Chatbot  ·  10</a:t>
+            </a:r>
+          </a:p>
+        </p:txBody>
+      </p:sp>
+    </p:spTree>
+  </p:cSld>
+  <p:clrMapOvr>
+    <a:masterClrMapping/>
+  </p:clrMapOvr>
+</p:sld>
+</file>
+
+<file path=ppt/slides/slide11.xml><?xml version="1.0" encoding="utf-8"?>
+<p:sld xmlns:a="http://schemas.openxmlformats.org/drawingml/2006/main" xmlns:p="http://schemas.openxmlformats.org/presentationml/2006/main" xmlns:r="http://schemas.openxmlformats.org/officeDocument/2006/relationships">
+  <p:cSld>
+    <p:spTree>
+      <p:nvGrpSpPr>
+        <p:cNvPr id="1" name=""/>
+        <p:cNvGrpSpPr/>
+        <p:nvPr/>
+      </p:nvGrpSpPr>
+      <p:grpSpPr/>
+      <p:sp>
+        <p:nvSpPr>
+          <p:cNvPr id="2" name="Rectangle 1"/>
+          <p:cNvSpPr/>
+          <p:nvPr/>
+        </p:nvSpPr>
+        <p:spPr>
+          <a:xfrm>
+            <a:off x="0" y="0"/>
+            <a:ext cx="9144000" cy="822960"/>
+          </a:xfrm>
+          <a:prstGeom prst="rect">
+            <a:avLst/>
+          </a:prstGeom>
+          <a:solidFill>
+            <a:srgbClr val="2D6A4F"/>
+          </a:solidFill>
+          <a:ln>
+            <a:noFill/>
+          </a:ln>
+        </p:spPr>
+        <p:style>
+          <a:lnRef idx="1">
+            <a:schemeClr val="accent1"/>
+          </a:lnRef>
+          <a:fillRef idx="3">
+            <a:schemeClr val="accent1"/>
+          </a:fillRef>
+          <a:effectRef idx="2">
+            <a:schemeClr val="accent1"/>
+          </a:effectRef>
+          <a:fontRef idx="minor">
+            <a:schemeClr val="lt1"/>
+          </a:fontRef>
+        </p:style>
+        <p:txBody>
+          <a:bodyPr rtlCol="0" anchor="ctr" lIns="457200" wrap="square"/>
+          <a:lstStyle/>
+          <a:p>
+            <a:pPr algn="ctr"/>
+            <a:r>
+              <a:rPr sz="2600" b="1">
+                <a:solidFill>
+                  <a:srgbClr val="FFFFFF"/>
+                </a:solidFill>
+              </a:rPr>
+              <a:t>Provenance, sources &amp; AI usage</a:t>
+            </a:r>
+          </a:p>
+        </p:txBody>
+      </p:sp>
+      <p:sp>
+        <p:nvSpPr>
+          <p:cNvPr id="3" name="Rectangle 2"/>
+          <p:cNvSpPr/>
+          <p:nvPr/>
+        </p:nvSpPr>
+        <p:spPr>
+          <a:xfrm>
+            <a:off x="365760" y="1051560"/>
+            <a:ext cx="4160520" cy="1143000"/>
+          </a:xfrm>
+          <a:prstGeom prst="rect">
+            <a:avLst/>
+          </a:prstGeom>
+          <a:solidFill>
+            <a:srgbClr val="F2F7F4"/>
+          </a:solidFill>
+          <a:ln w="12700">
+            <a:solidFill>
+              <a:srgbClr val="2D6A4F"/>
+            </a:solidFill>
+          </a:ln>
+        </p:spPr>
+        <p:style>
+          <a:lnRef idx="1">
+            <a:schemeClr val="accent1"/>
+          </a:lnRef>
+          <a:fillRef idx="3">
+            <a:schemeClr val="accent1"/>
+          </a:fillRef>
+          <a:effectRef idx="2">
+            <a:schemeClr val="accent1"/>
+          </a:effectRef>
+          <a:fontRef idx="minor">
+            <a:schemeClr val="lt1"/>
+          </a:fontRef>
+        </p:style>
+        <p:txBody>
+          <a:bodyPr rtlCol="0" anchor="ctr" wrap="square" lIns="164592" rIns="164592" tIns="128016"/>
+          <a:lstStyle/>
+          <a:p>
+            <a:pPr algn="ctr"/>
+            <a:r>
+              <a:rPr sz="1400" b="1">
+                <a:solidFill>
+                  <a:srgbClr val="1B4332"/>
+                </a:solidFill>
+              </a:rPr>
+              <a:t>Corpus</a:t>
+            </a:r>
+          </a:p>
+          <a:p>
+            <a:r>
+              <a:rPr sz="1150">
+                <a:solidFill>
+                  <a:srgbClr val="5A6B62"/>
+                </a:solidFill>
+              </a:rPr>
+              <a:t>Laws of the Game 2025/26 (single pages), © IFAB/FIFA — not authored by us, no reproduction permission obtained. chunks.json is a derived research artifact; the PDF is not committed. See data/source_metadata.json.</a:t>
+            </a:r>
+          </a:p>
+        </p:txBody>
+      </p:sp>
+      <p:sp>
+        <p:nvSpPr>
+          <p:cNvPr id="4" name="Rectangle 3"/>
+          <p:cNvSpPr/>
+          <p:nvPr/>
+        </p:nvSpPr>
+        <p:spPr>
+          <a:xfrm>
+            <a:off x="4617720" y="1051560"/>
+            <a:ext cx="4160520" cy="1143000"/>
+          </a:xfrm>
+          <a:prstGeom prst="rect">
+            <a:avLst/>
+          </a:prstGeom>
+          <a:solidFill>
+            <a:srgbClr val="F2F7F4"/>
+          </a:solidFill>
+          <a:ln w="12700">
+            <a:solidFill>
+              <a:srgbClr val="2D6A4F"/>
+            </a:solidFill>
+          </a:ln>
+        </p:spPr>
+        <p:style>
+          <a:lnRef idx="1">
+            <a:schemeClr val="accent1"/>
+          </a:lnRef>
+          <a:fillRef idx="3">
+            <a:schemeClr val="accent1"/>
+          </a:fillRef>
+          <a:effectRef idx="2">
+            <a:schemeClr val="accent1"/>
+          </a:effectRef>
+          <a:fontRef idx="minor">
+            <a:schemeClr val="lt1"/>
+          </a:fontRef>
+        </p:style>
+        <p:txBody>
+          <a:bodyPr rtlCol="0" anchor="ctr" wrap="square" lIns="164592" rIns="164592" tIns="128016"/>
+          <a:lstStyle/>
+          <a:p>
+            <a:pPr algn="ctr"/>
+            <a:r>
+              <a:rPr sz="1400" b="1">
+                <a:solidFill>
+                  <a:srgbClr val="1B4332"/>
+                </a:solidFill>
+              </a:rPr>
+              <a:t>Reproducibility</a:t>
+            </a:r>
+          </a:p>
+          <a:p>
+            <a:r>
+              <a:rPr sz="1150">
+                <a:solidFill>
+                  <a:srgbClr val="5A6B62"/>
+                </a:solidFill>
+              </a:rPr>
+              <a:t>Offline (no key): tests, retrieval eval, regression check. Needs Groq key: generation. Needs the PDF: regenerating the corpus. Tested on Python 3.10 &amp; 3.12 in CI.</a:t>
+            </a:r>
+          </a:p>
+        </p:txBody>
+      </p:sp>
+      <p:sp>
+        <p:nvSpPr>
+          <p:cNvPr id="5" name="Rectangle 4"/>
+          <p:cNvSpPr/>
+          <p:nvPr/>
+        </p:nvSpPr>
+        <p:spPr>
+          <a:xfrm>
+            <a:off x="365760" y="2423160"/>
+            <a:ext cx="4160520" cy="1143000"/>
+          </a:xfrm>
+          <a:prstGeom prst="rect">
+            <a:avLst/>
+          </a:prstGeom>
+          <a:solidFill>
+            <a:srgbClr val="F2F7F4"/>
+          </a:solidFill>
+          <a:ln w="12700">
+            <a:solidFill>
+              <a:srgbClr val="2D6A4F"/>
+            </a:solidFill>
+          </a:ln>
+        </p:spPr>
+        <p:style>
+          <a:lnRef idx="1">
+            <a:schemeClr val="accent1"/>
+          </a:lnRef>
+          <a:fillRef idx="3">
+            <a:schemeClr val="accent1"/>
+          </a:fillRef>
+          <a:effectRef idx="2">
+            <a:schemeClr val="accent1"/>
+          </a:effectRef>
+          <a:fontRef idx="minor">
+            <a:schemeClr val="lt1"/>
+          </a:fontRef>
+        </p:style>
+        <p:txBody>
+          <a:bodyPr rtlCol="0" anchor="ctr" wrap="square" lIns="164592" rIns="164592" tIns="128016"/>
+          <a:lstStyle/>
+          <a:p>
+            <a:pPr algn="ctr"/>
+            <a:r>
+              <a:rPr sz="1400" b="1">
+                <a:solidFill>
+                  <a:srgbClr val="1B4332"/>
+                </a:solidFill>
+              </a:rPr>
+              <a:t>Links</a:t>
+            </a:r>
+          </a:p>
+          <a:p>
+            <a:r>
+              <a:rPr sz="1150">
+                <a:solidFill>
+                  <a:srgbClr val="5A6B62"/>
+                </a:solidFill>
+              </a:rPr>
+              <a:t>Demo: fifa-rag.vercel.app · Repo: github.com/harish885/fifa-rag-chatbot · Vercel limits &amp; Groq model docs cited in README.</a:t>
+            </a:r>
+          </a:p>
+        </p:txBody>
+      </p:sp>
+      <p:sp>
+        <p:nvSpPr>
+          <p:cNvPr id="6" name="Rectangle 5"/>
+          <p:cNvSpPr/>
+          <p:nvPr/>
+        </p:nvSpPr>
+        <p:spPr>
+          <a:xfrm>
+            <a:off x="4617720" y="2423160"/>
+            <a:ext cx="4160520" cy="1143000"/>
+          </a:xfrm>
+          <a:prstGeom prst="rect">
+            <a:avLst/>
+          </a:prstGeom>
+          <a:solidFill>
+            <a:srgbClr val="F2F7F4"/>
+          </a:solidFill>
+          <a:ln w="12700">
+            <a:solidFill>
+              <a:srgbClr val="2D6A4F"/>
+            </a:solidFill>
+          </a:ln>
+        </p:spPr>
+        <p:style>
+          <a:lnRef idx="1">
+            <a:schemeClr val="accent1"/>
+          </a:lnRef>
+          <a:fillRef idx="3">
+            <a:schemeClr val="accent1"/>
+          </a:fillRef>
+          <a:effectRef idx="2">
+            <a:schemeClr val="accent1"/>
+          </a:effectRef>
+          <a:fontRef idx="minor">
+            <a:schemeClr val="lt1"/>
+          </a:fontRef>
+        </p:style>
+        <p:txBody>
+          <a:bodyPr rtlCol="0" anchor="ctr" wrap="square" lIns="164592" rIns="164592" tIns="128016"/>
+          <a:lstStyle/>
+          <a:p>
+            <a:pPr algn="ctr"/>
+            <a:r>
+              <a:rPr sz="1400" b="1">
+                <a:solidFill>
+                  <a:srgbClr val="1B4332"/>
+                </a:solidFill>
+              </a:rPr>
+              <a:t>AI usage</a:t>
+            </a:r>
+          </a:p>
+          <a:p>
+            <a:r>
+              <a:rPr sz="1150">
+                <a:solidFill>
+                  <a:srgbClr val="5A6B62"/>
+                </a:solidFill>
+              </a:rPr>
+              <a:t>Built with Claude (code, hardening, drafting). Problem framing, evaluation design, interpretation and all human labelling are ours. Human answer-scoring &amp; held-out labelling are outstanding. Full disclosure in README: AI usage.</a:t>
+            </a:r>
+          </a:p>
+        </p:txBody>
+      </p:sp>
+      <p:sp>
+        <p:nvSpPr>
+          <p:cNvPr id="7" name="TextBox 6"/>
+          <p:cNvSpPr txBox="1"/>
+          <p:nvPr/>
+        </p:nvSpPr>
+        <p:spPr>
+          <a:xfrm>
+            <a:off x="365760" y="4777740"/>
+            <a:ext cx="5486400" cy="274320"/>
+          </a:xfrm>
+          <a:prstGeom prst="rect">
+            <a:avLst/>
+          </a:prstGeom>
+          <a:noFill/>
+        </p:spPr>
+        <p:txBody>
+          <a:bodyPr wrap="none">
+            <a:spAutoFit/>
+          </a:bodyPr>
+          <a:lstStyle/>
+          <a:p>
+            <a:r>
+              <a:rPr sz="900">
+                <a:solidFill>
+                  <a:srgbClr val="5A6B62"/>
+                </a:solidFill>
+              </a:rPr>
+              <a:t>Laws of the Game RAG Chatbot  ·  11</a:t>
+            </a:r>
+          </a:p>
+        </p:txBody>
+      </p:sp>
+    </p:spTree>
+  </p:cSld>
+  <p:clrMapOvr>
+    <a:masterClrMapping/>
+  </p:clrMapOvr>
+</p:sld>
+</file>
+
+<file path=ppt/slides/slide12.xml><?xml version="1.0" encoding="utf-8"?>
 <p:sld xmlns:a="http://schemas.openxmlformats.org/drawingml/2006/main" xmlns:r="http://schemas.openxmlformats.org/officeDocument/2006/relationships" xmlns:p="http://schemas.openxmlformats.org/presentationml/2006/main">
   <p:cSld name="Slide 10">
     <p:bg>
@@ -2294,70 +3037,7 @@
                 <a:ea typeface="Calibri" pitchFamily="34" charset="-122"/>
                 <a:cs typeface="Calibri" pitchFamily="34" charset="-120"/>
               </a:rPr>
-              <a:t>A constraint-driven design: free serverless deployment shaped a lexical-first retrieval choice — and the evaluation validated it.</a:t>
-            </a:r>
-            <a:endParaRPr lang="en-US" sz="1350" dirty="0"/>
-          </a:p>
-          <a:p>
-            <a:pPr marL="342900" indent="-342900">
-              <a:spcAft>
-                <a:spcPts val="800"/>
-              </a:spcAft>
-              <a:buSzPct val="100000"/>
-              <a:buChar char="•"/>
-            </a:pPr>
-            <a:r>
-              <a:rPr lang="en-US" sz="1350" dirty="0">
-                <a:solidFill>
-                  <a:srgbClr val="E8F4EC"/>
-                </a:solidFill>
-                <a:latin typeface="Calibri" pitchFamily="34" charset="0"/>
-                <a:ea typeface="Calibri" pitchFamily="34" charset="-122"/>
-                <a:cs typeface="Calibri" pitchFamily="34" charset="-120"/>
-              </a:rPr>
-              <a:t>The register gap (colloquial vs legal football language) is the corpus's core difficulty; a glossary-derived expansion map closed most of it (+10 pts Recall@5, verified by ablation).</a:t>
-            </a:r>
-            <a:endParaRPr lang="en-US" sz="1350" dirty="0"/>
-          </a:p>
-          <a:p>
-            <a:pPr marL="342900" indent="-342900">
-              <a:spcAft>
-                <a:spcPts val="800"/>
-              </a:spcAft>
-              <a:buSzPct val="100000"/>
-              <a:buChar char="•"/>
-            </a:pPr>
-            <a:r>
-              <a:rPr lang="en-US" sz="1350" dirty="0">
-                <a:solidFill>
-                  <a:srgbClr val="E8F4EC"/>
-                </a:solidFill>
-                <a:latin typeface="Calibri" pitchFamily="34" charset="0"/>
-                <a:ea typeface="Calibri" pitchFamily="34" charset="-122"/>
-                <a:cs typeface="Calibri" pitchFamily="34" charset="-120"/>
-              </a:rPr>
-              <a:t>Every answer is grounded and page-cited; out-of-corpus questions are refused.</a:t>
-            </a:r>
-            <a:endParaRPr lang="en-US" sz="1350" dirty="0"/>
-          </a:p>
-          <a:p>
-            <a:pPr marL="342900" indent="-342900">
-              <a:spcAft>
-                <a:spcPts val="800"/>
-              </a:spcAft>
-              <a:buSzPct val="100000"/>
-              <a:buChar char="•"/>
-            </a:pPr>
-            <a:r>
-              <a:rPr lang="en-US" sz="1350" dirty="0">
-                <a:solidFill>
-                  <a:srgbClr val="E8F4EC"/>
-                </a:solidFill>
-                <a:latin typeface="Calibri" pitchFamily="34" charset="0"/>
-                <a:ea typeface="Calibri" pitchFamily="34" charset="-122"/>
-                <a:cs typeface="Calibri" pitchFamily="34" charset="-120"/>
-              </a:rPr>
-              <a:t>Full pipeline is reproducible: ingest → index → evaluate → deploy, all in the repo.</a:t>
+              <a:t>A constraint-driven design: the free serverless target shaped a lexical-first retrieval choice; the development-set evaluation is consistent with it (not a held-out validation). The register gap (colloquial vs legal football language) is the corpus's core difficulty, and query expansion measurably helps. Answers cite pages you can verify; retrieval evaluation does not prove answer correctness — human answer scoring is still to come.</a:t>
             </a:r>
             <a:endParaRPr lang="en-US" sz="1350" dirty="0"/>
           </a:p>
@@ -2477,7 +3157,7 @@
                 <a:ea typeface="Calibri" pitchFamily="34" charset="-122"/>
                 <a:cs typeface="Calibri" pitchFamily="34" charset="-120"/>
               </a:rPr>
-              <a:t>AI usage: built with assistance from Claude (code scaffolding, debugging, slide drafting) — design choices, evaluation methodology and interpretation are our own. Full disclosure in README §7.</a:t>
+              <a:t>AI usage: built with assistance from Claude (code, hardening, drafting) — problem framing, evaluation design, interpretation, and all human labelling are ours. Full disclosure in README: AI usage.</a:t>
             </a:r>
             <a:endParaRPr lang="en-US" sz="1050" dirty="0"/>
           </a:p>
@@ -2861,7 +3541,7 @@
                 <a:ea typeface="Georgia" pitchFamily="34" charset="-122"/>
                 <a:cs typeface="Georgia" pitchFamily="34" charset="-120"/>
               </a:rPr>
-              <a:t>277</a:t>
+              <a:t>267</a:t>
             </a:r>
             <a:endParaRPr lang="en-US" sz="3400" dirty="0"/>
           </a:p>
@@ -2900,7 +3580,7 @@
                 <a:ea typeface="Calibri" pitchFamily="34" charset="-122"/>
                 <a:cs typeface="Calibri" pitchFamily="34" charset="-120"/>
               </a:rPr>
-              <a:t>page-tagged chunks after ingestion</a:t>
+              <a:t>chunks from text pages 4–217 (not every PDF page)</a:t>
             </a:r>
             <a:endParaRPr lang="en-US" sz="1150" dirty="0"/>
           </a:p>
@@ -2939,7 +3619,7 @@
                 <a:ea typeface="Calibri" pitchFamily="34" charset="-122"/>
                 <a:cs typeface="Calibri" pitchFamily="34" charset="-120"/>
               </a:rPr>
-              <a:t>Goal. </a:t>
+              <a:t>Goal. Answer natural-language rules questions grounded only in the official document, with page citations you can check.</a:t>
             </a:r>
             <a:r>
               <a:rPr lang="en-US" sz="1400" dirty="0">
@@ -2950,7 +3630,7 @@
                 <a:ea typeface="Calibri" pitchFamily="34" charset="-122"/>
                 <a:cs typeface="Calibri" pitchFamily="34" charset="-120"/>
               </a:rPr>
-              <a:t>Answer natural-language rules questions grounded exclusively in the official document, with page citations so every claim is verifiable.</a:t>
+              <a:t/>
             </a:r>
             <a:endParaRPr lang="en-US" sz="1400" dirty="0"/>
           </a:p>
@@ -3111,7 +3791,7 @@
                 <a:ea typeface="Georgia" pitchFamily="34" charset="-122"/>
                 <a:cs typeface="Georgia" pitchFamily="34" charset="-120"/>
               </a:rPr>
-              <a:t>Architecture: lean RAG, zero-cost serving</a:t>
+              <a:t>Architecture: lean RAG, low-cost serving</a:t>
             </a:r>
             <a:endParaRPr lang="en-US" sz="2700" dirty="0"/>
           </a:p>
@@ -3415,7 +4095,7 @@
                 <a:ea typeface="Calibri" pitchFamily="34" charset="-122"/>
                 <a:cs typeface="Calibri" pitchFamily="34" charset="-120"/>
               </a:rPr>
-              <a:t>PyMuPDF · ~1100-char chunks · 200 overlap · page tags</a:t>
+              <a:t>PyMuPDF · cleaned text · sentence-aware ~1100-char chunks · page tags</a:t>
             </a:r>
             <a:endParaRPr lang="en-US" sz="1000" dirty="0"/>
           </a:p>
@@ -3563,7 +4243,7 @@
                 <a:ea typeface="Calibri" pitchFamily="34" charset="-122"/>
                 <a:cs typeface="Calibri" pitchFamily="34" charset="-120"/>
               </a:rPr>
-              <a:t>277 chunks shipped inside the function</a:t>
+              <a:t>267 chunks shipped inside the function</a:t>
             </a:r>
             <a:endParaRPr lang="en-US" sz="1000" dirty="0"/>
           </a:p>
@@ -3867,7 +4547,7 @@
                 <a:ea typeface="Calibri" pitchFamily="34" charset="-122"/>
                 <a:cs typeface="Calibri" pitchFamily="34" charset="-120"/>
               </a:rPr>
-              <a:t>colloquial → official: red card → sending-off (16-entry map)</a:t>
+              <a:t>history-aware; colloquial → official (red card → sending-off), word-boundary map</a:t>
             </a:r>
             <a:endParaRPr lang="en-US" sz="1000" dirty="0"/>
           </a:p>
@@ -3976,7 +4656,7 @@
                 <a:ea typeface="Calibri" pitchFamily="34" charset="-122"/>
                 <a:cs typeface="Calibri" pitchFamily="34" charset="-120"/>
               </a:rPr>
-              <a:t>BM25 top-5</a:t>
+              <a:t>BM25 page-diverse top-5</a:t>
             </a:r>
             <a:endParaRPr lang="en-US" sz="1250" dirty="0"/>
           </a:p>
@@ -4015,7 +4695,7 @@
                 <a:ea typeface="Calibri" pitchFamily="34" charset="-122"/>
                 <a:cs typeface="Calibri" pitchFamily="34" charset="-120"/>
               </a:rPr>
-              <a:t>in-memory index, &lt;1 ms, built at cold start</a:t>
+              <a:t>in-memory index, built at cold start</a:t>
             </a:r>
             <a:endParaRPr lang="en-US" sz="1000" dirty="0"/>
           </a:p>
@@ -4163,7 +4843,7 @@
                 <a:ea typeface="Calibri" pitchFamily="34" charset="-122"/>
                 <a:cs typeface="Calibri" pitchFamily="34" charset="-120"/>
               </a:rPr>
-              <a:t>Groq free tier, ~800 tok/s — cited answer</a:t>
+              <a:t>Groq free tier — JSON answer; citations validated</a:t>
             </a:r>
             <a:endParaRPr lang="en-US" sz="1000" dirty="0"/>
           </a:p>
@@ -4418,7 +5098,7 @@
                 <a:ea typeface="Calibri" pitchFamily="34" charset="-122"/>
                 <a:cs typeface="Calibri" pitchFamily="34" charset="-120"/>
               </a:rPr>
-              <a:t>One terminology-dense rulebook → exact terms carry the signal. Fully interpretable scores made our error analysis possible. Index builds in &lt;50 ms at cold start, zero ML dependencies.</a:t>
+              <a:t>One terminology-dense rulebook → exact terms carry the signal. Fully interpretable scores made our error analysis possible. Builds from JSON at cold start with no ML model to download.</a:t>
             </a:r>
             <a:endParaRPr lang="en-US" sz="1050" dirty="0"/>
           </a:p>
@@ -4562,7 +5242,7 @@
                 <a:ea typeface="Calibri" pitchFamily="34" charset="-122"/>
                 <a:cs typeface="Calibri" pitchFamily="34" charset="-120"/>
               </a:rPr>
-              <a:t>Chunk ≈ one rule subsection, so a single hit usually contains the full provision. Page tags give verifiable citations and double as free ground-truth labels for evaluation.</a:t>
+              <a:t>Chunk ≈ one rule subsection, so a single hit usually contains the full provision. Page tags give verifiable citations and coarse page-level labels for evaluation.</a:t>
             </a:r>
             <a:endParaRPr lang="en-US" sz="1050" dirty="0"/>
           </a:p>
@@ -4706,7 +5386,7 @@
                 <a:ea typeface="Calibri" pitchFamily="34" charset="-122"/>
                 <a:cs typeface="Calibri" pitchFamily="34" charset="-120"/>
               </a:rPr>
-              <a:t>Bottleneck is retrieval, not generation — 8B suffices to paraphrase rule text. ~800 tok/s at $0. Prompt forbids answering outside context and requires page citations (hallucination guard).</a:t>
+              <a:t>8B paraphrases retrieved rule text well for this task; we did not benchmark larger models. Temperature 0; prompt forbids answering outside context and requires page citations.</a:t>
             </a:r>
             <a:endParaRPr lang="en-US" sz="1050" dirty="0"/>
           </a:p>
@@ -4850,7 +5530,7 @@
                 <a:ea typeface="Calibri" pitchFamily="34" charset="-122"/>
                 <a:cs typeface="Calibri" pitchFamily="34" charset="-120"/>
               </a:rPr>
-              <a:t>One Python function + one HTML file. No DB, no vector store, free hosting. The 250 MB function limit is a real constraint that shaped the retrieval choice — a deliberate trade-off.</a:t>
+              <a:t>One Python function + one HTML file. No DB, no vector store. Vercel Python functions allow up to 500 MB (official docs); ours is far smaller. The free-serverless target shaped the retrieval choice.</a:t>
             </a:r>
             <a:endParaRPr lang="en-US" sz="1050" dirty="0"/>
           </a:p>
@@ -5098,7 +5778,7 @@
                 <a:ea typeface="Calibri" pitchFamily="34" charset="-122"/>
                 <a:cs typeface="Calibri" pitchFamily="34" charset="-120"/>
               </a:rPr>
-              <a:t>Better paraphrase recall in principle, but: embedding model exceeds Vercel's function limit; a hosted vector DB adds cost, latency and ops for a 277-chunk corpus; dense scores are hard to debug.  </a:t>
+              <a:t>Better paraphrase recall in principle. We did not benchmark a dense retriever; we chose against it for simplicity, interpretability, the small 267-chunk corpus, and the free serverless target — not because it 'cannot work'.</a:t>
             </a:r>
             <a:r>
               <a:rPr lang="en-US" sz="1050" i="1" dirty="0">
@@ -5109,7 +5789,7 @@
                 <a:ea typeface="Calibri" pitchFamily="34" charset="-122"/>
                 <a:cs typeface="Calibri" pitchFamily="34" charset="-120"/>
               </a:rPr>
-              <a:t>Our measured BM25 weakness (vocabulary mismatch) was fixable with a 16-entry synonym map instead — verified by ablation (+10 pts R@5).</a:t>
+              <a:t/>
             </a:r>
             <a:endParaRPr lang="en-US" sz="1050" dirty="0"/>
           </a:p>
@@ -5394,7 +6074,7 @@
                 <a:ea typeface="Calibri" pitchFamily="34" charset="-122"/>
                 <a:cs typeface="Calibri" pitchFamily="34" charset="-120"/>
               </a:rPr>
-              <a:t>More latency and cost with no measurable benefit: our evaluation shows the bottleneck is retrieval, not generation.  </a:t>
+              <a:t>A larger generator was not prioritized: we focused evaluation effort on retrieval. Generator-size comparison remains future work.</a:t>
             </a:r>
             <a:r>
               <a:rPr lang="en-US" sz="1050" i="1" dirty="0">
@@ -5405,7 +6085,7 @@
                 <a:ea typeface="Calibri" pitchFamily="34" charset="-122"/>
                 <a:cs typeface="Calibri" pitchFamily="34" charset="-120"/>
               </a:rPr>
-              <a:t>8B + retrieved context already answers correctly when retrieval hits.</a:t>
+              <a:t/>
             </a:r>
             <a:endParaRPr lang="en-US" sz="1050" dirty="0"/>
           </a:p>
@@ -5621,7 +6301,7 @@
                 <a:ea typeface="Calibri" pitchFamily="34" charset="-122"/>
                 <a:cs typeface="Calibri" pitchFamily="34" charset="-120"/>
               </a:rPr>
-              <a:t>Gold labels. </a:t>
+              <a:t>Development set. 20 questions hand-labelled with the gold PDF page(s) (eval/eval_set.json, laws_dev_v1). Used to develop the expansion map → results are optimistic, not held-out. Page labels are coarse.</a:t>
             </a:r>
             <a:r>
               <a:rPr lang="en-US" sz="1250" dirty="0">
@@ -5632,7 +6312,7 @@
                 <a:ea typeface="Calibri" pitchFamily="34" charset="-122"/>
                 <a:cs typeface="Calibri" pitchFamily="34" charset="-120"/>
               </a:rPr>
-              <a:t>20 natural-language questions hand-labelled with the official PDF page(s) containing the answer (eval/eval_set.json). Page tags from ingestion make labelling cheap and unambiguous.</a:t>
+              <a:t/>
             </a:r>
             <a:endParaRPr lang="en-US" sz="1250" dirty="0"/>
           </a:p>
@@ -5737,7 +6417,7 @@
                 <a:ea typeface="Calibri" pitchFamily="34" charset="-122"/>
                 <a:cs typeface="Calibri" pitchFamily="34" charset="-120"/>
               </a:rPr>
-              <a:t>Metrics. </a:t>
+              <a:t>Metrics. Page Hit Rate@k (hit@k) = any top-k chunk on a gold page — NOT IR recall. Plus page-level MRR@5 and unique-pages@5, with 95% Wilson CIs.</a:t>
             </a:r>
             <a:r>
               <a:rPr lang="en-US" sz="1250" dirty="0">
@@ -5748,7 +6428,7 @@
                 <a:ea typeface="Calibri" pitchFamily="34" charset="-122"/>
                 <a:cs typeface="Calibri" pitchFamily="34" charset="-120"/>
               </a:rPr>
-              <a:t>Hit = any top-k chunk lies on a gold page. We report Recall@1/3/5 and MRR@5. Recall@5 matters most: the generator reads the top-5 chunks, so the answer only needs to be somewhere in them.</a:t>
+              <a:t/>
             </a:r>
             <a:endParaRPr lang="en-US" sz="1250" dirty="0"/>
           </a:p>
@@ -5853,7 +6533,7 @@
                 <a:ea typeface="Calibri" pitchFamily="34" charset="-122"/>
                 <a:cs typeface="Calibri" pitchFamily="34" charset="-120"/>
               </a:rPr>
-              <a:t>Four systems. </a:t>
+              <a:t>Systems compared. Production (expansion + page-dedup) · no-dedup · no-expansion ablation · TF-IDF baseline · random floor.</a:t>
             </a:r>
             <a:r>
               <a:rPr lang="en-US" sz="1250" dirty="0">
@@ -5864,7 +6544,7 @@
                 <a:ea typeface="Calibri" pitchFamily="34" charset="-122"/>
                 <a:cs typeface="Calibri" pitchFamily="34" charset="-120"/>
               </a:rPr>
-              <a:t>Production (BM25 + expansion) · plain BM25 (ablation isolates expansion's contribution) · TF-IDF cosine (classical baseline) · random retrieval (sanity floor).</a:t>
+              <a:t/>
             </a:r>
             <a:endParaRPr lang="en-US" sz="1250" dirty="0"/>
           </a:p>
@@ -5969,7 +6649,7 @@
                 <a:ea typeface="Calibri" pitchFamily="34" charset="-122"/>
                 <a:cs typeface="Calibri" pitchFamily="34" charset="-120"/>
               </a:rPr>
-              <a:t>Qualitative. </a:t>
+              <a:t>Qualitative. Per-query error analysis; a human answer-level rubric (harness committed, scores pending) plus deterministic citation checks. Automated retrieval eval is kept separate from human review.</a:t>
             </a:r>
             <a:r>
               <a:rPr lang="en-US" sz="1250" dirty="0">
@@ -5980,7 +6660,7 @@
                 <a:ea typeface="Calibri" pitchFamily="34" charset="-122"/>
                 <a:cs typeface="Calibri" pitchFamily="34" charset="-120"/>
               </a:rPr>
-              <a:t>Manual inspection of every miss (error analysis); spot-checks that answers cite correct pages and that out-of-corpus questions (“who won the 2022 World Cup?”) are refused.</a:t>
+              <a:t/>
             </a:r>
             <a:endParaRPr lang="en-US" sz="1250" dirty="0"/>
           </a:p>
@@ -6152,7 +6832,7 @@
                 <a:ea typeface="Georgia" pitchFamily="34" charset="-122"/>
                 <a:cs typeface="Georgia" pitchFamily="34" charset="-120"/>
               </a:rPr>
-              <a:t>Results: 0.80 Recall@5 in production</a:t>
+              <a:t>Results: Page Hit Rate@5 = 0.75 (development set)</a:t>
             </a:r>
             <a:endParaRPr lang="en-US" sz="2700" dirty="0"/>
           </a:p>
@@ -6241,7 +6921,7 @@
                 <a:ea typeface="Georgia" pitchFamily="34" charset="-122"/>
                 <a:cs typeface="Georgia" pitchFamily="34" charset="-120"/>
               </a:rPr>
-              <a:t>0.80</a:t>
+              <a:t>0.75</a:t>
             </a:r>
             <a:endParaRPr lang="en-US" sz="4400" dirty="0"/>
           </a:p>
@@ -6280,7 +6960,7 @@
                 <a:ea typeface="Calibri" pitchFamily="34" charset="-122"/>
                 <a:cs typeface="Calibri" pitchFamily="34" charset="-120"/>
               </a:rPr>
-              <a:t>Recall@5, production (16× the random floor)</a:t>
+              <a:t>Page Hit Rate@5 = 15/20 · development set · 95% Wilson CI [0.53, 0.89]</a:t>
             </a:r>
             <a:endParaRPr lang="en-US" sz="1050" dirty="0"/>
           </a:p>
@@ -6319,7 +6999,7 @@
                 <a:ea typeface="Calibri" pitchFamily="34" charset="-122"/>
                 <a:cs typeface="Calibri" pitchFamily="34" charset="-120"/>
               </a:rPr>
-              <a:t>Ablation: </a:t>
+              <a:t>Ablation: query expansion adds +0.10 hit@5, no regressions.   TF-IDF trails BM25 (0.55 vs 0.75 hit@5).   n=20 is small — the CI is wide and not evidence of generalization.</a:t>
             </a:r>
             <a:r>
               <a:rPr lang="en-US" sz="1100" dirty="0">
@@ -6330,71 +7010,37 @@
                 <a:ea typeface="Calibri" pitchFamily="34" charset="-122"/>
                 <a:cs typeface="Calibri" pitchFamily="34" charset="-120"/>
               </a:rPr>
-              <a:t>query expansion adds +10 pts R@5, +4 MRR, no regressions.</a:t>
+              <a:t/>
             </a:r>
             <a:endParaRPr lang="en-US" sz="1100" dirty="0"/>
           </a:p>
+        </p:txBody>
+      </p:sp>
+      <p:sp>
+        <p:nvSpPr>
+          <p:cNvPr id="8" name="Text 5"/>
+          <p:cNvSpPr/>
+          <p:nvPr/>
+        </p:nvSpPr>
+        <p:spPr>
+          <a:xfrm>
+            <a:off x="502920" y="4526280"/>
+            <a:ext cx="4572000" cy="228600"/>
+          </a:xfrm>
+          <a:prstGeom prst="rect">
+            <a:avLst/>
+          </a:prstGeom>
+          <a:noFill/>
+          <a:ln/>
+        </p:spPr>
+        <p:txBody>
+          <a:bodyPr wrap="square" lIns="0" tIns="0" rIns="0" bIns="0" rtlCol="0" anchor="ctr"/>
+          <a:lstStyle/>
           <a:p>
             <a:pPr marL="0" indent="0">
               <a:buNone/>
             </a:pPr>
             <a:r>
-              <a:rPr lang="en-US" sz="1100" dirty="0">
-                <a:solidFill>
-                  <a:srgbClr val="000000"/>
-                </a:solidFill>
-                <a:latin typeface="Calibri" pitchFamily="34" charset="0"/>
-                <a:ea typeface="Calibri" pitchFamily="34" charset="-122"/>
-                <a:cs typeface="Calibri" pitchFamily="34" charset="-120"/>
-              </a:rPr>
-              <a:t> </a:t>
-            </a:r>
-            <a:endParaRPr lang="en-US" sz="1100" dirty="0"/>
-          </a:p>
-          <a:p>
-            <a:pPr marL="0" indent="0">
-              <a:buNone/>
-            </a:pPr>
-            <a:r>
-              <a:rPr lang="en-US" sz="1100" dirty="0">
-                <a:solidFill>
-                  <a:srgbClr val="1B2A23"/>
-                </a:solidFill>
-                <a:latin typeface="Calibri" pitchFamily="34" charset="0"/>
-                <a:ea typeface="Calibri" pitchFamily="34" charset="-122"/>
-                <a:cs typeface="Calibri" pitchFamily="34" charset="-120"/>
-              </a:rPr>
-              <a:t>TF-IDF edges R@1 but loses at R@5 — BM25's length normalisation wins as k grows; production uses k = 5.</a:t>
-            </a:r>
-            <a:endParaRPr lang="en-US" sz="1100" dirty="0"/>
-          </a:p>
-        </p:txBody>
-      </p:sp>
-      <p:sp>
-        <p:nvSpPr>
-          <p:cNvPr id="8" name="Text 5"/>
-          <p:cNvSpPr/>
-          <p:nvPr/>
-        </p:nvSpPr>
-        <p:spPr>
-          <a:xfrm>
-            <a:off x="502920" y="4526280"/>
-            <a:ext cx="4572000" cy="228600"/>
-          </a:xfrm>
-          <a:prstGeom prst="rect">
-            <a:avLst/>
-          </a:prstGeom>
-          <a:noFill/>
-          <a:ln/>
-        </p:spPr>
-        <p:txBody>
-          <a:bodyPr wrap="square" lIns="0" tIns="0" rIns="0" bIns="0" rtlCol="0" anchor="ctr"/>
-          <a:lstStyle/>
-          <a:p>
-            <a:pPr marL="0" indent="0">
-              <a:buNone/>
-            </a:pPr>
-            <a:r>
               <a:rPr lang="en-US" sz="850" i="1" dirty="0">
                 <a:solidFill>
                   <a:srgbClr val="5C6F65"/>
@@ -6403,7 +7049,7 @@
                 <a:ea typeface="Calibri" pitchFamily="34" charset="-122"/>
                 <a:cs typeface="Calibri" pitchFamily="34" charset="-120"/>
               </a:rPr>
-              <a:t>Random Recall@1 = 0.00 — no visible bar.</a:t>
+              <a:t>Random hit@1 = 0.05 — near the floor.</a:t>
             </a:r>
             <a:endParaRPr lang="en-US" sz="850" dirty="0"/>
           </a:p>
@@ -6670,7 +7316,7 @@
                 <a:ea typeface="Calibri" pitchFamily="34" charset="-122"/>
                 <a:cs typeface="Calibri" pitchFamily="34" charset="-120"/>
               </a:rPr>
-              <a:t>Plain BM25: Recall@5 = 0.70. Six misses on 20 queries.</a:t>
+              <a:t>Plain BM25 (no expansion): hit@5 = 0.65. 7 misses on 20 queries.</a:t>
             </a:r>
             <a:endParaRPr lang="en-US" sz="1000" dirty="0"/>
           </a:p>
@@ -6818,7 +7464,7 @@
                 <a:ea typeface="Calibri" pitchFamily="34" charset="-122"/>
                 <a:cs typeface="Calibri" pitchFamily="34" charset="-120"/>
               </a:rPr>
-              <a:t>All misses share one cause: vocabulary mismatch. “red card” vs “sending-off offence”, “how long” vs “duration”.</a:t>
+              <a:t>Several misses involve vocabulary mismatch (red card vs sending-off; how long vs duration) — but not all share one cause.</a:t>
             </a:r>
             <a:endParaRPr lang="en-US" sz="1000" dirty="0"/>
           </a:p>
@@ -6966,7 +7612,7 @@
                 <a:ea typeface="Calibri" pitchFamily="34" charset="-122"/>
                 <a:cs typeface="Calibri" pitchFamily="34" charset="-120"/>
               </a:rPr>
-              <a:t>16-entry query-expansion map taken from the document's own glossary — not from the eval set's wording.</a:t>
+              <a:t>16-entry map: most entries glossary-derived, some motivated by dev-set error analysis (disclosed in rag/expansion.py).</a:t>
             </a:r>
             <a:endParaRPr lang="en-US" sz="1000" dirty="0"/>
           </a:p>
@@ -7114,7 +7760,7 @@
                 <a:ea typeface="Calibri" pitchFamily="34" charset="-122"/>
                 <a:cs typeface="Calibri" pitchFamily="34" charset="-120"/>
               </a:rPr>
-              <a:t>Recall@5 → 0.80, MRR → 0.56. Exactly the diagnosed queries flip to hits; nothing else changes.</a:t>
+              <a:t>hit@5 → 0.75. Two queries flip to hits; expansion fires without effect on others; no regressions (verified query by query).</a:t>
             </a:r>
             <a:endParaRPr lang="en-US" sz="1000" dirty="0"/>
           </a:p>
@@ -7153,7 +7799,7 @@
                 <a:ea typeface="Calibri" pitchFamily="34" charset="-122"/>
                 <a:cs typeface="Calibri" pitchFamily="34" charset="-120"/>
               </a:rPr>
-              <a:t>Remaining 4 misses — two identifiable causes:</a:t>
+              <a:t>Remaining 5 misses — multiple causes (not a single cause):</a:t>
             </a:r>
             <a:endParaRPr lang="en-US" sz="1250" dirty="0"/>
           </a:p>
@@ -7192,7 +7838,7 @@
                 <a:ea typeface="Calibri" pitchFamily="34" charset="-122"/>
                 <a:cs typeface="Calibri" pitchFamily="34" charset="-120"/>
               </a:rPr>
-              <a:t>Front-matter collisions — </a:t>
+              <a:t>Observed categories: front-matter collision (yellow-card → Notes pages outrank Law 12); domain-adjacent confusion (extra-time → half-time page); low-information query (when is a goal scored); specific-provision dilution (GK position, wall distance). Page-dedup removes duplicate-page context waste. Index/heading fixes remain proposals.</a:t>
             </a:r>
             <a:r>
               <a:rPr lang="en-US" sz="1150" dirty="0">
@@ -7203,7 +7849,7 @@
                 <a:ea typeface="Calibri" pitchFamily="34" charset="-122"/>
                 <a:cs typeface="Calibri" pitchFamily="34" charset="-120"/>
               </a:rPr>
-              <a:t>the “Summary of Law changes” section repeats key terms densely enough to outrank the actual Law text.  </a:t>
+              <a:t/>
             </a:r>
             <a:r>
               <a:rPr lang="en-US" sz="1150" i="1" dirty="0">
@@ -7214,63 +7860,7 @@
                 <a:ea typeface="Calibri" pitchFamily="34" charset="-122"/>
                 <a:cs typeface="Calibri" pitchFamily="34" charset="-120"/>
               </a:rPr>
-              <a:t>Mitigation: exclude front matter from the index.</a:t>
-            </a:r>
-            <a:endParaRPr lang="en-US" sz="1150" dirty="0"/>
-          </a:p>
-          <a:p>
-            <a:pPr marL="0" indent="0">
-              <a:buNone/>
-            </a:pPr>
-            <a:r>
-              <a:rPr lang="en-US" sz="400" dirty="0">
-                <a:solidFill>
-                  <a:srgbClr val="000000"/>
-                </a:solidFill>
-                <a:latin typeface="Calibri" pitchFamily="34" charset="0"/>
-                <a:ea typeface="Calibri" pitchFamily="34" charset="-122"/>
-                <a:cs typeface="Calibri" pitchFamily="34" charset="-120"/>
-              </a:rPr>
-              <a:t> </a:t>
-            </a:r>
-            <a:endParaRPr lang="en-US" sz="1150" dirty="0"/>
-          </a:p>
-          <a:p>
-            <a:pPr marL="0" indent="0">
-              <a:buNone/>
-            </a:pPr>
-            <a:r>
-              <a:rPr lang="en-US" sz="1150" b="1" dirty="0">
-                <a:solidFill>
-                  <a:srgbClr val="1B4332"/>
-                </a:solidFill>
-                <a:latin typeface="Calibri" pitchFamily="34" charset="0"/>
-                <a:ea typeface="Calibri" pitchFamily="34" charset="-122"/>
-                <a:cs typeface="Calibri" pitchFamily="34" charset="-120"/>
-              </a:rPr>
-              <a:t>Low-information queries — </a:t>
-            </a:r>
-            <a:r>
-              <a:rPr lang="en-US" sz="1150" dirty="0">
-                <a:solidFill>
-                  <a:srgbClr val="1B2A23"/>
-                </a:solidFill>
-                <a:latin typeface="Calibri" pitchFamily="34" charset="0"/>
-                <a:ea typeface="Calibri" pitchFamily="34" charset="-122"/>
-                <a:cs typeface="Calibri" pitchFamily="34" charset="-120"/>
-              </a:rPr>
-              <a:t>“When is a goal scored?” has two content words, both ubiquitous in this corpus.  </a:t>
-            </a:r>
-            <a:r>
-              <a:rPr lang="en-US" sz="1150" i="1" dirty="0">
-                <a:solidFill>
-                  <a:srgbClr val="2D6A4F"/>
-                </a:solidFill>
-                <a:latin typeface="Calibri" pitchFamily="34" charset="0"/>
-                <a:ea typeface="Calibri" pitchFamily="34" charset="-122"/>
-                <a:cs typeface="Calibri" pitchFamily="34" charset="-120"/>
-              </a:rPr>
-              <a:t>Mitigation: boost chunks containing Law headings.</a:t>
+              <a:t/>
             </a:r>
             <a:endParaRPr lang="en-US" sz="1150" dirty="0"/>
           </a:p>
@@ -7518,7 +8108,7 @@
                 <a:ea typeface="Calibri" pitchFamily="34" charset="-122"/>
                 <a:cs typeface="Calibri" pitchFamily="34" charset="-120"/>
               </a:rPr>
-              <a:t>Expansion gains are optimistic — we tuned on what we measure. Next: a held-out test set written by someone who hasn't seen the synonym map.</a:t>
+              <a:t>Expansion gains are optimistic — we tuned on what we measure. Next: a held-out test set written by someone who hasn't seen the synonym map, double-annotated and frozen first.</a:t>
             </a:r>
             <a:endParaRPr lang="en-US" sz="1050" dirty="0"/>
           </a:p>
@@ -7792,7 +8382,7 @@
                 <a:ea typeface="Calibri" pitchFamily="34" charset="-122"/>
                 <a:cs typeface="Calibri" pitchFamily="34" charset="-120"/>
               </a:rPr>
-              <a:t>We measure whether the right page is retrieved, not final answer quality. Next: LLM-as-judge grading of answer faithfulness against gold pages.</a:t>
+              <a:t>We measure whether the right page is retrieved, not answer correctness (page labels are coarse). Next: human rubric scoring (harness committed, scores pending); any LLM judge would be provisional only.</a:t>
             </a:r>
             <a:endParaRPr lang="en-US" sz="1050" dirty="0"/>
           </a:p>
@@ -7929,7 +8519,7 @@
                 <a:ea typeface="Calibri" pitchFamily="34" charset="-122"/>
                 <a:cs typeface="Calibri" pitchFamily="34" charset="-120"/>
               </a:rPr>
-              <a:t>English-only, one rulebook. The pipeline is corpus-agnostic: re-running ingest.py swaps the domain.</a:t>
+              <a:t>English-only, one rulebook/edition. Adaptable to another corpus with domain-specific config — NOT corpus-agnostic (prompt &amp; expansion are football-specific). Also: model/provider dependency and corpus copyright/provenance.</a:t>
             </a:r>
             <a:endParaRPr lang="en-US" sz="1050" dirty="0"/>
           </a:p>

</xml_diff>